<commit_message>
Deck 9: add fade transitions and automatic fade-in builds
Applied tools/polish.py: 0.7 s fade between slides; diagram groups, pictures and captions fade in automatically in order, with no clicks. Titles, tag chips, slide numbers and credits stay in place. Content is unchanged.

Co-Authored-By: Claude Sonnet 5.5 <noreply@anthropic.com>
</commit_message>
<xml_diff>
--- a/Reporting/Claude Presents/Deck9_Balance/How_the_Mod_Is_Balanced_Explained.pptx
+++ b/Reporting/Claude Presents/Deck9_Balance/How_the_Mod_Is_Balanced_Explained.pptx
@@ -3306,6 +3306,174 @@
   <p:clrMapOvr>
     <a:masterClrMapping/>
   </p:clrMapOvr>
+  <mc:AlternateContent xmlns:mc="http://schemas.openxmlformats.org/markup-compatibility/2006">
+    <mc:Choice xmlns:p14="http://schemas.microsoft.com/office/powerpoint/2010/main" Requires="p14">
+      <p:transition spd="med" p14:dur="700">
+        <p:fade/>
+      </p:transition>
+    </mc:Choice>
+    <mc:Fallback>
+      <p:transition spd="med">
+        <p:fade/>
+      </p:transition>
+    </mc:Fallback>
+  </mc:AlternateContent>
+  <p:timing>
+    <p:tnLst>
+      <p:par>
+        <p:cTn id="1" dur="indefinite" restart="never" nodeType="tmRoot">
+          <p:childTnLst>
+            <p:seq concurrent="1" nextAc="seek">
+              <p:cTn id="2" dur="indefinite" nodeType="mainSeq">
+                <p:childTnLst>
+                  <p:par>
+                    <p:cTn id="3" fill="hold">
+                      <p:stCondLst>
+                        <p:cond delay="indefinite"/>
+                        <p:cond evt="onBegin" delay="0">
+                          <p:tn val="2"/>
+                        </p:cond>
+                      </p:stCondLst>
+                      <p:childTnLst>
+                        <p:par>
+                          <p:cTn id="4" fill="hold">
+                            <p:stCondLst>
+                              <p:cond delay="0"/>
+                            </p:stCondLst>
+                            <p:childTnLst>
+                              <p:par>
+                                <p:cTn id="5" presetID="10" presetClass="entr" presetSubtype="0" fill="hold" nodeType="afterEffect">
+                                  <p:stCondLst>
+                                    <p:cond delay="0"/>
+                                  </p:stCondLst>
+                                  <p:childTnLst>
+                                    <p:set>
+                                      <p:cBhvr>
+                                        <p:cTn id="6" dur="1" fill="hold">
+                                          <p:stCondLst>
+                                            <p:cond delay="0"/>
+                                          </p:stCondLst>
+                                        </p:cTn>
+                                        <p:tgtEl>
+                                          <p:spTgt spid="3"/>
+                                        </p:tgtEl>
+                                        <p:attrNameLst>
+                                          <p:attrName>style.visibility</p:attrName>
+                                        </p:attrNameLst>
+                                      </p:cBhvr>
+                                      <p:to>
+                                        <p:strVal val="visible"/>
+                                      </p:to>
+                                    </p:set>
+                                    <p:animEffect transition="in" filter="fade">
+                                      <p:cBhvr>
+                                        <p:cTn id="7" dur="500"/>
+                                        <p:tgtEl>
+                                          <p:spTgt spid="3"/>
+                                        </p:tgtEl>
+                                      </p:cBhvr>
+                                    </p:animEffect>
+                                  </p:childTnLst>
+                                </p:cTn>
+                              </p:par>
+                              <p:par>
+                                <p:cTn id="8" presetID="10" presetClass="entr" presetSubtype="0" fill="hold" nodeType="withEffect">
+                                  <p:stCondLst>
+                                    <p:cond delay="300"/>
+                                  </p:stCondLst>
+                                  <p:childTnLst>
+                                    <p:set>
+                                      <p:cBhvr>
+                                        <p:cTn id="9" dur="1" fill="hold">
+                                          <p:stCondLst>
+                                            <p:cond delay="0"/>
+                                          </p:stCondLst>
+                                        </p:cTn>
+                                        <p:tgtEl>
+                                          <p:spTgt spid="4"/>
+                                        </p:tgtEl>
+                                        <p:attrNameLst>
+                                          <p:attrName>style.visibility</p:attrName>
+                                        </p:attrNameLst>
+                                      </p:cBhvr>
+                                      <p:to>
+                                        <p:strVal val="visible"/>
+                                      </p:to>
+                                    </p:set>
+                                    <p:animEffect transition="in" filter="fade">
+                                      <p:cBhvr>
+                                        <p:cTn id="10" dur="500"/>
+                                        <p:tgtEl>
+                                          <p:spTgt spid="4"/>
+                                        </p:tgtEl>
+                                      </p:cBhvr>
+                                    </p:animEffect>
+                                  </p:childTnLst>
+                                </p:cTn>
+                              </p:par>
+                              <p:par>
+                                <p:cTn id="11" presetID="10" presetClass="entr" presetSubtype="0" fill="hold" nodeType="withEffect">
+                                  <p:stCondLst>
+                                    <p:cond delay="600"/>
+                                  </p:stCondLst>
+                                  <p:childTnLst>
+                                    <p:set>
+                                      <p:cBhvr>
+                                        <p:cTn id="12" dur="1" fill="hold">
+                                          <p:stCondLst>
+                                            <p:cond delay="0"/>
+                                          </p:stCondLst>
+                                        </p:cTn>
+                                        <p:tgtEl>
+                                          <p:spTgt spid="5"/>
+                                        </p:tgtEl>
+                                        <p:attrNameLst>
+                                          <p:attrName>style.visibility</p:attrName>
+                                        </p:attrNameLst>
+                                      </p:cBhvr>
+                                      <p:to>
+                                        <p:strVal val="visible"/>
+                                      </p:to>
+                                    </p:set>
+                                    <p:animEffect transition="in" filter="fade">
+                                      <p:cBhvr>
+                                        <p:cTn id="13" dur="500"/>
+                                        <p:tgtEl>
+                                          <p:spTgt spid="5"/>
+                                        </p:tgtEl>
+                                      </p:cBhvr>
+                                    </p:animEffect>
+                                  </p:childTnLst>
+                                </p:cTn>
+                              </p:par>
+                            </p:childTnLst>
+                          </p:cTn>
+                        </p:par>
+                      </p:childTnLst>
+                    </p:cTn>
+                  </p:par>
+                </p:childTnLst>
+              </p:cTn>
+              <p:prevCondLst>
+                <p:cond evt="onPrev" delay="0">
+                  <p:tgtEl>
+                    <p:sldTgt/>
+                  </p:tgtEl>
+                </p:cond>
+              </p:prevCondLst>
+              <p:nextCondLst>
+                <p:cond evt="onNext" delay="0">
+                  <p:tgtEl>
+                    <p:sldTgt/>
+                  </p:tgtEl>
+                </p:cond>
+              </p:nextCondLst>
+            </p:seq>
+          </p:childTnLst>
+        </p:cTn>
+      </p:par>
+    </p:tnLst>
+  </p:timing>
 </p:sld>
 </file>
 
@@ -4528,6 +4696,279 @@
   <p:clrMapOvr>
     <a:masterClrMapping/>
   </p:clrMapOvr>
+  <mc:AlternateContent xmlns:mc="http://schemas.openxmlformats.org/markup-compatibility/2006">
+    <mc:Choice xmlns:p14="http://schemas.microsoft.com/office/powerpoint/2010/main" Requires="p14">
+      <p:transition spd="med" p14:dur="700">
+        <p:fade/>
+      </p:transition>
+    </mc:Choice>
+    <mc:Fallback>
+      <p:transition spd="med">
+        <p:fade/>
+      </p:transition>
+    </mc:Fallback>
+  </mc:AlternateContent>
+  <p:timing>
+    <p:tnLst>
+      <p:par>
+        <p:cTn id="1" dur="indefinite" restart="never" nodeType="tmRoot">
+          <p:childTnLst>
+            <p:seq concurrent="1" nextAc="seek">
+              <p:cTn id="2" dur="indefinite" nodeType="mainSeq">
+                <p:childTnLst>
+                  <p:par>
+                    <p:cTn id="3" fill="hold">
+                      <p:stCondLst>
+                        <p:cond delay="indefinite"/>
+                        <p:cond evt="onBegin" delay="0">
+                          <p:tn val="2"/>
+                        </p:cond>
+                      </p:stCondLst>
+                      <p:childTnLst>
+                        <p:par>
+                          <p:cTn id="4" fill="hold">
+                            <p:stCondLst>
+                              <p:cond delay="0"/>
+                            </p:stCondLst>
+                            <p:childTnLst>
+                              <p:par>
+                                <p:cTn id="5" presetID="10" presetClass="entr" presetSubtype="0" fill="hold" nodeType="afterEffect">
+                                  <p:stCondLst>
+                                    <p:cond delay="0"/>
+                                  </p:stCondLst>
+                                  <p:childTnLst>
+                                    <p:set>
+                                      <p:cBhvr>
+                                        <p:cTn id="6" dur="1" fill="hold">
+                                          <p:stCondLst>
+                                            <p:cond delay="0"/>
+                                          </p:stCondLst>
+                                        </p:cTn>
+                                        <p:tgtEl>
+                                          <p:spTgt spid="4"/>
+                                        </p:tgtEl>
+                                        <p:attrNameLst>
+                                          <p:attrName>style.visibility</p:attrName>
+                                        </p:attrNameLst>
+                                      </p:cBhvr>
+                                      <p:to>
+                                        <p:strVal val="visible"/>
+                                      </p:to>
+                                    </p:set>
+                                    <p:animEffect transition="in" filter="fade">
+                                      <p:cBhvr>
+                                        <p:cTn id="7" dur="500"/>
+                                        <p:tgtEl>
+                                          <p:spTgt spid="4"/>
+                                        </p:tgtEl>
+                                      </p:cBhvr>
+                                    </p:animEffect>
+                                  </p:childTnLst>
+                                </p:cTn>
+                              </p:par>
+                              <p:par>
+                                <p:cTn id="8" presetID="10" presetClass="entr" presetSubtype="0" fill="hold" nodeType="withEffect">
+                                  <p:stCondLst>
+                                    <p:cond delay="300"/>
+                                  </p:stCondLst>
+                                  <p:childTnLst>
+                                    <p:set>
+                                      <p:cBhvr>
+                                        <p:cTn id="9" dur="1" fill="hold">
+                                          <p:stCondLst>
+                                            <p:cond delay="0"/>
+                                          </p:stCondLst>
+                                        </p:cTn>
+                                        <p:tgtEl>
+                                          <p:spTgt spid="16"/>
+                                        </p:tgtEl>
+                                        <p:attrNameLst>
+                                          <p:attrName>style.visibility</p:attrName>
+                                        </p:attrNameLst>
+                                      </p:cBhvr>
+                                      <p:to>
+                                        <p:strVal val="visible"/>
+                                      </p:to>
+                                    </p:set>
+                                    <p:animEffect transition="in" filter="fade">
+                                      <p:cBhvr>
+                                        <p:cTn id="10" dur="500"/>
+                                        <p:tgtEl>
+                                          <p:spTgt spid="16"/>
+                                        </p:tgtEl>
+                                      </p:cBhvr>
+                                    </p:animEffect>
+                                  </p:childTnLst>
+                                </p:cTn>
+                              </p:par>
+                              <p:par>
+                                <p:cTn id="11" presetID="10" presetClass="entr" presetSubtype="0" fill="hold" nodeType="withEffect">
+                                  <p:stCondLst>
+                                    <p:cond delay="600"/>
+                                  </p:stCondLst>
+                                  <p:childTnLst>
+                                    <p:set>
+                                      <p:cBhvr>
+                                        <p:cTn id="12" dur="1" fill="hold">
+                                          <p:stCondLst>
+                                            <p:cond delay="0"/>
+                                          </p:stCondLst>
+                                        </p:cTn>
+                                        <p:tgtEl>
+                                          <p:spTgt spid="28"/>
+                                        </p:tgtEl>
+                                        <p:attrNameLst>
+                                          <p:attrName>style.visibility</p:attrName>
+                                        </p:attrNameLst>
+                                      </p:cBhvr>
+                                      <p:to>
+                                        <p:strVal val="visible"/>
+                                      </p:to>
+                                    </p:set>
+                                    <p:animEffect transition="in" filter="fade">
+                                      <p:cBhvr>
+                                        <p:cTn id="13" dur="500"/>
+                                        <p:tgtEl>
+                                          <p:spTgt spid="28"/>
+                                        </p:tgtEl>
+                                      </p:cBhvr>
+                                    </p:animEffect>
+                                  </p:childTnLst>
+                                </p:cTn>
+                              </p:par>
+                              <p:par>
+                                <p:cTn id="14" presetID="10" presetClass="entr" presetSubtype="0" fill="hold" nodeType="withEffect">
+                                  <p:stCondLst>
+                                    <p:cond delay="900"/>
+                                  </p:stCondLst>
+                                  <p:childTnLst>
+                                    <p:set>
+                                      <p:cBhvr>
+                                        <p:cTn id="15" dur="1" fill="hold">
+                                          <p:stCondLst>
+                                            <p:cond delay="0"/>
+                                          </p:stCondLst>
+                                        </p:cTn>
+                                        <p:tgtEl>
+                                          <p:spTgt spid="30"/>
+                                        </p:tgtEl>
+                                        <p:attrNameLst>
+                                          <p:attrName>style.visibility</p:attrName>
+                                        </p:attrNameLst>
+                                      </p:cBhvr>
+                                      <p:to>
+                                        <p:strVal val="visible"/>
+                                      </p:to>
+                                    </p:set>
+                                    <p:animEffect transition="in" filter="fade">
+                                      <p:cBhvr>
+                                        <p:cTn id="16" dur="500"/>
+                                        <p:tgtEl>
+                                          <p:spTgt spid="30"/>
+                                        </p:tgtEl>
+                                      </p:cBhvr>
+                                    </p:animEffect>
+                                  </p:childTnLst>
+                                </p:cTn>
+                              </p:par>
+                              <p:par>
+                                <p:cTn id="17" presetID="10" presetClass="entr" presetSubtype="0" fill="hold" nodeType="withEffect">
+                                  <p:stCondLst>
+                                    <p:cond delay="1200"/>
+                                  </p:stCondLst>
+                                  <p:childTnLst>
+                                    <p:set>
+                                      <p:cBhvr>
+                                        <p:cTn id="18" dur="1" fill="hold">
+                                          <p:stCondLst>
+                                            <p:cond delay="0"/>
+                                          </p:stCondLst>
+                                        </p:cTn>
+                                        <p:tgtEl>
+                                          <p:spTgt spid="31"/>
+                                        </p:tgtEl>
+                                        <p:attrNameLst>
+                                          <p:attrName>style.visibility</p:attrName>
+                                        </p:attrNameLst>
+                                      </p:cBhvr>
+                                      <p:to>
+                                        <p:strVal val="visible"/>
+                                      </p:to>
+                                    </p:set>
+                                    <p:animEffect transition="in" filter="fade">
+                                      <p:cBhvr>
+                                        <p:cTn id="19" dur="500"/>
+                                        <p:tgtEl>
+                                          <p:spTgt spid="31"/>
+                                        </p:tgtEl>
+                                      </p:cBhvr>
+                                    </p:animEffect>
+                                  </p:childTnLst>
+                                </p:cTn>
+                              </p:par>
+                              <p:par>
+                                <p:cTn id="20" presetID="10" presetClass="entr" presetSubtype="0" fill="hold" nodeType="withEffect">
+                                  <p:stCondLst>
+                                    <p:cond delay="1500"/>
+                                  </p:stCondLst>
+                                  <p:childTnLst>
+                                    <p:set>
+                                      <p:cBhvr>
+                                        <p:cTn id="21" dur="1" fill="hold">
+                                          <p:stCondLst>
+                                            <p:cond delay="0"/>
+                                          </p:stCondLst>
+                                        </p:cTn>
+                                        <p:tgtEl>
+                                          <p:spTgt spid="32"/>
+                                        </p:tgtEl>
+                                        <p:attrNameLst>
+                                          <p:attrName>style.visibility</p:attrName>
+                                        </p:attrNameLst>
+                                      </p:cBhvr>
+                                      <p:to>
+                                        <p:strVal val="visible"/>
+                                      </p:to>
+                                    </p:set>
+                                    <p:animEffect transition="in" filter="fade">
+                                      <p:cBhvr>
+                                        <p:cTn id="22" dur="500"/>
+                                        <p:tgtEl>
+                                          <p:spTgt spid="32"/>
+                                        </p:tgtEl>
+                                      </p:cBhvr>
+                                    </p:animEffect>
+                                  </p:childTnLst>
+                                </p:cTn>
+                              </p:par>
+                            </p:childTnLst>
+                          </p:cTn>
+                        </p:par>
+                      </p:childTnLst>
+                    </p:cTn>
+                  </p:par>
+                </p:childTnLst>
+              </p:cTn>
+              <p:prevCondLst>
+                <p:cond evt="onPrev" delay="0">
+                  <p:tgtEl>
+                    <p:sldTgt/>
+                  </p:tgtEl>
+                </p:cond>
+              </p:prevCondLst>
+              <p:nextCondLst>
+                <p:cond evt="onNext" delay="0">
+                  <p:tgtEl>
+                    <p:sldTgt/>
+                  </p:tgtEl>
+                </p:cond>
+              </p:nextCondLst>
+            </p:seq>
+          </p:childTnLst>
+        </p:cTn>
+      </p:par>
+    </p:tnLst>
+  </p:timing>
 </p:sld>
 </file>
 
@@ -7142,6 +7583,174 @@
   <p:clrMapOvr>
     <a:masterClrMapping/>
   </p:clrMapOvr>
+  <mc:AlternateContent xmlns:mc="http://schemas.openxmlformats.org/markup-compatibility/2006">
+    <mc:Choice xmlns:p14="http://schemas.microsoft.com/office/powerpoint/2010/main" Requires="p14">
+      <p:transition spd="med" p14:dur="700">
+        <p:fade/>
+      </p:transition>
+    </mc:Choice>
+    <mc:Fallback>
+      <p:transition spd="med">
+        <p:fade/>
+      </p:transition>
+    </mc:Fallback>
+  </mc:AlternateContent>
+  <p:timing>
+    <p:tnLst>
+      <p:par>
+        <p:cTn id="1" dur="indefinite" restart="never" nodeType="tmRoot">
+          <p:childTnLst>
+            <p:seq concurrent="1" nextAc="seek">
+              <p:cTn id="2" dur="indefinite" nodeType="mainSeq">
+                <p:childTnLst>
+                  <p:par>
+                    <p:cTn id="3" fill="hold">
+                      <p:stCondLst>
+                        <p:cond delay="indefinite"/>
+                        <p:cond evt="onBegin" delay="0">
+                          <p:tn val="2"/>
+                        </p:cond>
+                      </p:stCondLst>
+                      <p:childTnLst>
+                        <p:par>
+                          <p:cTn id="4" fill="hold">
+                            <p:stCondLst>
+                              <p:cond delay="0"/>
+                            </p:stCondLst>
+                            <p:childTnLst>
+                              <p:par>
+                                <p:cTn id="5" presetID="10" presetClass="entr" presetSubtype="0" fill="hold" nodeType="afterEffect">
+                                  <p:stCondLst>
+                                    <p:cond delay="0"/>
+                                  </p:stCondLst>
+                                  <p:childTnLst>
+                                    <p:set>
+                                      <p:cBhvr>
+                                        <p:cTn id="6" dur="1" fill="hold">
+                                          <p:stCondLst>
+                                            <p:cond delay="0"/>
+                                          </p:stCondLst>
+                                        </p:cTn>
+                                        <p:tgtEl>
+                                          <p:spTgt spid="4"/>
+                                        </p:tgtEl>
+                                        <p:attrNameLst>
+                                          <p:attrName>style.visibility</p:attrName>
+                                        </p:attrNameLst>
+                                      </p:cBhvr>
+                                      <p:to>
+                                        <p:strVal val="visible"/>
+                                      </p:to>
+                                    </p:set>
+                                    <p:animEffect transition="in" filter="fade">
+                                      <p:cBhvr>
+                                        <p:cTn id="7" dur="500"/>
+                                        <p:tgtEl>
+                                          <p:spTgt spid="4"/>
+                                        </p:tgtEl>
+                                      </p:cBhvr>
+                                    </p:animEffect>
+                                  </p:childTnLst>
+                                </p:cTn>
+                              </p:par>
+                              <p:par>
+                                <p:cTn id="8" presetID="10" presetClass="entr" presetSubtype="0" fill="hold" nodeType="withEffect">
+                                  <p:stCondLst>
+                                    <p:cond delay="300"/>
+                                  </p:stCondLst>
+                                  <p:childTnLst>
+                                    <p:set>
+                                      <p:cBhvr>
+                                        <p:cTn id="9" dur="1" fill="hold">
+                                          <p:stCondLst>
+                                            <p:cond delay="0"/>
+                                          </p:stCondLst>
+                                        </p:cTn>
+                                        <p:tgtEl>
+                                          <p:spTgt spid="72"/>
+                                        </p:tgtEl>
+                                        <p:attrNameLst>
+                                          <p:attrName>style.visibility</p:attrName>
+                                        </p:attrNameLst>
+                                      </p:cBhvr>
+                                      <p:to>
+                                        <p:strVal val="visible"/>
+                                      </p:to>
+                                    </p:set>
+                                    <p:animEffect transition="in" filter="fade">
+                                      <p:cBhvr>
+                                        <p:cTn id="10" dur="500"/>
+                                        <p:tgtEl>
+                                          <p:spTgt spid="72"/>
+                                        </p:tgtEl>
+                                      </p:cBhvr>
+                                    </p:animEffect>
+                                  </p:childTnLst>
+                                </p:cTn>
+                              </p:par>
+                              <p:par>
+                                <p:cTn id="11" presetID="10" presetClass="entr" presetSubtype="0" fill="hold" nodeType="withEffect">
+                                  <p:stCondLst>
+                                    <p:cond delay="600"/>
+                                  </p:stCondLst>
+                                  <p:childTnLst>
+                                    <p:set>
+                                      <p:cBhvr>
+                                        <p:cTn id="12" dur="1" fill="hold">
+                                          <p:stCondLst>
+                                            <p:cond delay="0"/>
+                                          </p:stCondLst>
+                                        </p:cTn>
+                                        <p:tgtEl>
+                                          <p:spTgt spid="79"/>
+                                        </p:tgtEl>
+                                        <p:attrNameLst>
+                                          <p:attrName>style.visibility</p:attrName>
+                                        </p:attrNameLst>
+                                      </p:cBhvr>
+                                      <p:to>
+                                        <p:strVal val="visible"/>
+                                      </p:to>
+                                    </p:set>
+                                    <p:animEffect transition="in" filter="fade">
+                                      <p:cBhvr>
+                                        <p:cTn id="13" dur="500"/>
+                                        <p:tgtEl>
+                                          <p:spTgt spid="79"/>
+                                        </p:tgtEl>
+                                      </p:cBhvr>
+                                    </p:animEffect>
+                                  </p:childTnLst>
+                                </p:cTn>
+                              </p:par>
+                            </p:childTnLst>
+                          </p:cTn>
+                        </p:par>
+                      </p:childTnLst>
+                    </p:cTn>
+                  </p:par>
+                </p:childTnLst>
+              </p:cTn>
+              <p:prevCondLst>
+                <p:cond evt="onPrev" delay="0">
+                  <p:tgtEl>
+                    <p:sldTgt/>
+                  </p:tgtEl>
+                </p:cond>
+              </p:prevCondLst>
+              <p:nextCondLst>
+                <p:cond evt="onNext" delay="0">
+                  <p:tgtEl>
+                    <p:sldTgt/>
+                  </p:tgtEl>
+                </p:cond>
+              </p:nextCondLst>
+            </p:seq>
+          </p:childTnLst>
+        </p:cTn>
+      </p:par>
+    </p:tnLst>
+  </p:timing>
 </p:sld>
 </file>
 
@@ -8816,6 +9425,384 @@
   <p:clrMapOvr>
     <a:masterClrMapping/>
   </p:clrMapOvr>
+  <mc:AlternateContent xmlns:mc="http://schemas.openxmlformats.org/markup-compatibility/2006">
+    <mc:Choice xmlns:p14="http://schemas.microsoft.com/office/powerpoint/2010/main" Requires="p14">
+      <p:transition spd="med" p14:dur="700">
+        <p:fade/>
+      </p:transition>
+    </mc:Choice>
+    <mc:Fallback>
+      <p:transition spd="med">
+        <p:fade/>
+      </p:transition>
+    </mc:Fallback>
+  </mc:AlternateContent>
+  <p:timing>
+    <p:tnLst>
+      <p:par>
+        <p:cTn id="1" dur="indefinite" restart="never" nodeType="tmRoot">
+          <p:childTnLst>
+            <p:seq concurrent="1" nextAc="seek">
+              <p:cTn id="2" dur="indefinite" nodeType="mainSeq">
+                <p:childTnLst>
+                  <p:par>
+                    <p:cTn id="3" fill="hold">
+                      <p:stCondLst>
+                        <p:cond delay="indefinite"/>
+                        <p:cond evt="onBegin" delay="0">
+                          <p:tn val="2"/>
+                        </p:cond>
+                      </p:stCondLst>
+                      <p:childTnLst>
+                        <p:par>
+                          <p:cTn id="4" fill="hold">
+                            <p:stCondLst>
+                              <p:cond delay="0"/>
+                            </p:stCondLst>
+                            <p:childTnLst>
+                              <p:par>
+                                <p:cTn id="5" presetID="10" presetClass="entr" presetSubtype="0" fill="hold" nodeType="afterEffect">
+                                  <p:stCondLst>
+                                    <p:cond delay="0"/>
+                                  </p:stCondLst>
+                                  <p:childTnLst>
+                                    <p:set>
+                                      <p:cBhvr>
+                                        <p:cTn id="6" dur="1" fill="hold">
+                                          <p:stCondLst>
+                                            <p:cond delay="0"/>
+                                          </p:stCondLst>
+                                        </p:cTn>
+                                        <p:tgtEl>
+                                          <p:spTgt spid="4"/>
+                                        </p:tgtEl>
+                                        <p:attrNameLst>
+                                          <p:attrName>style.visibility</p:attrName>
+                                        </p:attrNameLst>
+                                      </p:cBhvr>
+                                      <p:to>
+                                        <p:strVal val="visible"/>
+                                      </p:to>
+                                    </p:set>
+                                    <p:animEffect transition="in" filter="fade">
+                                      <p:cBhvr>
+                                        <p:cTn id="7" dur="500"/>
+                                        <p:tgtEl>
+                                          <p:spTgt spid="4"/>
+                                        </p:tgtEl>
+                                      </p:cBhvr>
+                                    </p:animEffect>
+                                  </p:childTnLst>
+                                </p:cTn>
+                              </p:par>
+                              <p:par>
+                                <p:cTn id="8" presetID="10" presetClass="entr" presetSubtype="0" fill="hold" nodeType="withEffect">
+                                  <p:stCondLst>
+                                    <p:cond delay="200"/>
+                                  </p:stCondLst>
+                                  <p:childTnLst>
+                                    <p:set>
+                                      <p:cBhvr>
+                                        <p:cTn id="9" dur="1" fill="hold">
+                                          <p:stCondLst>
+                                            <p:cond delay="0"/>
+                                          </p:stCondLst>
+                                        </p:cTn>
+                                        <p:tgtEl>
+                                          <p:spTgt spid="9"/>
+                                        </p:tgtEl>
+                                        <p:attrNameLst>
+                                          <p:attrName>style.visibility</p:attrName>
+                                        </p:attrNameLst>
+                                      </p:cBhvr>
+                                      <p:to>
+                                        <p:strVal val="visible"/>
+                                      </p:to>
+                                    </p:set>
+                                    <p:animEffect transition="in" filter="fade">
+                                      <p:cBhvr>
+                                        <p:cTn id="10" dur="500"/>
+                                        <p:tgtEl>
+                                          <p:spTgt spid="9"/>
+                                        </p:tgtEl>
+                                      </p:cBhvr>
+                                    </p:animEffect>
+                                  </p:childTnLst>
+                                </p:cTn>
+                              </p:par>
+                              <p:par>
+                                <p:cTn id="11" presetID="10" presetClass="entr" presetSubtype="0" fill="hold" nodeType="withEffect">
+                                  <p:stCondLst>
+                                    <p:cond delay="400"/>
+                                  </p:stCondLst>
+                                  <p:childTnLst>
+                                    <p:set>
+                                      <p:cBhvr>
+                                        <p:cTn id="12" dur="1" fill="hold">
+                                          <p:stCondLst>
+                                            <p:cond delay="0"/>
+                                          </p:stCondLst>
+                                        </p:cTn>
+                                        <p:tgtEl>
+                                          <p:spTgt spid="15"/>
+                                        </p:tgtEl>
+                                        <p:attrNameLst>
+                                          <p:attrName>style.visibility</p:attrName>
+                                        </p:attrNameLst>
+                                      </p:cBhvr>
+                                      <p:to>
+                                        <p:strVal val="visible"/>
+                                      </p:to>
+                                    </p:set>
+                                    <p:animEffect transition="in" filter="fade">
+                                      <p:cBhvr>
+                                        <p:cTn id="13" dur="500"/>
+                                        <p:tgtEl>
+                                          <p:spTgt spid="15"/>
+                                        </p:tgtEl>
+                                      </p:cBhvr>
+                                    </p:animEffect>
+                                  </p:childTnLst>
+                                </p:cTn>
+                              </p:par>
+                              <p:par>
+                                <p:cTn id="14" presetID="10" presetClass="entr" presetSubtype="0" fill="hold" nodeType="withEffect">
+                                  <p:stCondLst>
+                                    <p:cond delay="600"/>
+                                  </p:stCondLst>
+                                  <p:childTnLst>
+                                    <p:set>
+                                      <p:cBhvr>
+                                        <p:cTn id="15" dur="1" fill="hold">
+                                          <p:stCondLst>
+                                            <p:cond delay="0"/>
+                                          </p:stCondLst>
+                                        </p:cTn>
+                                        <p:tgtEl>
+                                          <p:spTgt spid="21"/>
+                                        </p:tgtEl>
+                                        <p:attrNameLst>
+                                          <p:attrName>style.visibility</p:attrName>
+                                        </p:attrNameLst>
+                                      </p:cBhvr>
+                                      <p:to>
+                                        <p:strVal val="visible"/>
+                                      </p:to>
+                                    </p:set>
+                                    <p:animEffect transition="in" filter="fade">
+                                      <p:cBhvr>
+                                        <p:cTn id="16" dur="500"/>
+                                        <p:tgtEl>
+                                          <p:spTgt spid="21"/>
+                                        </p:tgtEl>
+                                      </p:cBhvr>
+                                    </p:animEffect>
+                                  </p:childTnLst>
+                                </p:cTn>
+                              </p:par>
+                              <p:par>
+                                <p:cTn id="17" presetID="10" presetClass="entr" presetSubtype="0" fill="hold" nodeType="withEffect">
+                                  <p:stCondLst>
+                                    <p:cond delay="800"/>
+                                  </p:stCondLst>
+                                  <p:childTnLst>
+                                    <p:set>
+                                      <p:cBhvr>
+                                        <p:cTn id="18" dur="1" fill="hold">
+                                          <p:stCondLst>
+                                            <p:cond delay="0"/>
+                                          </p:stCondLst>
+                                        </p:cTn>
+                                        <p:tgtEl>
+                                          <p:spTgt spid="26"/>
+                                        </p:tgtEl>
+                                        <p:attrNameLst>
+                                          <p:attrName>style.visibility</p:attrName>
+                                        </p:attrNameLst>
+                                      </p:cBhvr>
+                                      <p:to>
+                                        <p:strVal val="visible"/>
+                                      </p:to>
+                                    </p:set>
+                                    <p:animEffect transition="in" filter="fade">
+                                      <p:cBhvr>
+                                        <p:cTn id="19" dur="500"/>
+                                        <p:tgtEl>
+                                          <p:spTgt spid="26"/>
+                                        </p:tgtEl>
+                                      </p:cBhvr>
+                                    </p:animEffect>
+                                  </p:childTnLst>
+                                </p:cTn>
+                              </p:par>
+                              <p:par>
+                                <p:cTn id="20" presetID="10" presetClass="entr" presetSubtype="0" fill="hold" nodeType="withEffect">
+                                  <p:stCondLst>
+                                    <p:cond delay="1000"/>
+                                  </p:stCondLst>
+                                  <p:childTnLst>
+                                    <p:set>
+                                      <p:cBhvr>
+                                        <p:cTn id="21" dur="1" fill="hold">
+                                          <p:stCondLst>
+                                            <p:cond delay="0"/>
+                                          </p:stCondLst>
+                                        </p:cTn>
+                                        <p:tgtEl>
+                                          <p:spTgt spid="32"/>
+                                        </p:tgtEl>
+                                        <p:attrNameLst>
+                                          <p:attrName>style.visibility</p:attrName>
+                                        </p:attrNameLst>
+                                      </p:cBhvr>
+                                      <p:to>
+                                        <p:strVal val="visible"/>
+                                      </p:to>
+                                    </p:set>
+                                    <p:animEffect transition="in" filter="fade">
+                                      <p:cBhvr>
+                                        <p:cTn id="22" dur="500"/>
+                                        <p:tgtEl>
+                                          <p:spTgt spid="32"/>
+                                        </p:tgtEl>
+                                      </p:cBhvr>
+                                    </p:animEffect>
+                                  </p:childTnLst>
+                                </p:cTn>
+                              </p:par>
+                              <p:par>
+                                <p:cTn id="23" presetID="10" presetClass="entr" presetSubtype="0" fill="hold" nodeType="withEffect">
+                                  <p:stCondLst>
+                                    <p:cond delay="1200"/>
+                                  </p:stCondLst>
+                                  <p:childTnLst>
+                                    <p:set>
+                                      <p:cBhvr>
+                                        <p:cTn id="24" dur="1" fill="hold">
+                                          <p:stCondLst>
+                                            <p:cond delay="0"/>
+                                          </p:stCondLst>
+                                        </p:cTn>
+                                        <p:tgtEl>
+                                          <p:spTgt spid="41"/>
+                                        </p:tgtEl>
+                                        <p:attrNameLst>
+                                          <p:attrName>style.visibility</p:attrName>
+                                        </p:attrNameLst>
+                                      </p:cBhvr>
+                                      <p:to>
+                                        <p:strVal val="visible"/>
+                                      </p:to>
+                                    </p:set>
+                                    <p:animEffect transition="in" filter="fade">
+                                      <p:cBhvr>
+                                        <p:cTn id="25" dur="500"/>
+                                        <p:tgtEl>
+                                          <p:spTgt spid="41"/>
+                                        </p:tgtEl>
+                                      </p:cBhvr>
+                                    </p:animEffect>
+                                  </p:childTnLst>
+                                </p:cTn>
+                              </p:par>
+                              <p:par>
+                                <p:cTn id="26" presetID="10" presetClass="entr" presetSubtype="0" fill="hold" nodeType="withEffect">
+                                  <p:stCondLst>
+                                    <p:cond delay="1400"/>
+                                  </p:stCondLst>
+                                  <p:childTnLst>
+                                    <p:set>
+                                      <p:cBhvr>
+                                        <p:cTn id="27" dur="1" fill="hold">
+                                          <p:stCondLst>
+                                            <p:cond delay="0"/>
+                                          </p:stCondLst>
+                                        </p:cTn>
+                                        <p:tgtEl>
+                                          <p:spTgt spid="46"/>
+                                        </p:tgtEl>
+                                        <p:attrNameLst>
+                                          <p:attrName>style.visibility</p:attrName>
+                                        </p:attrNameLst>
+                                      </p:cBhvr>
+                                      <p:to>
+                                        <p:strVal val="visible"/>
+                                      </p:to>
+                                    </p:set>
+                                    <p:animEffect transition="in" filter="fade">
+                                      <p:cBhvr>
+                                        <p:cTn id="28" dur="500"/>
+                                        <p:tgtEl>
+                                          <p:spTgt spid="46"/>
+                                        </p:tgtEl>
+                                      </p:cBhvr>
+                                    </p:animEffect>
+                                  </p:childTnLst>
+                                </p:cTn>
+                              </p:par>
+                              <p:par>
+                                <p:cTn id="29" presetID="10" presetClass="entr" presetSubtype="0" fill="hold" nodeType="withEffect">
+                                  <p:stCondLst>
+                                    <p:cond delay="1600"/>
+                                  </p:stCondLst>
+                                  <p:childTnLst>
+                                    <p:set>
+                                      <p:cBhvr>
+                                        <p:cTn id="30" dur="1" fill="hold">
+                                          <p:stCondLst>
+                                            <p:cond delay="0"/>
+                                          </p:stCondLst>
+                                        </p:cTn>
+                                        <p:tgtEl>
+                                          <p:spTgt spid="52"/>
+                                        </p:tgtEl>
+                                        <p:attrNameLst>
+                                          <p:attrName>style.visibility</p:attrName>
+                                        </p:attrNameLst>
+                                      </p:cBhvr>
+                                      <p:to>
+                                        <p:strVal val="visible"/>
+                                      </p:to>
+                                    </p:set>
+                                    <p:animEffect transition="in" filter="fade">
+                                      <p:cBhvr>
+                                        <p:cTn id="31" dur="500"/>
+                                        <p:tgtEl>
+                                          <p:spTgt spid="52"/>
+                                        </p:tgtEl>
+                                      </p:cBhvr>
+                                    </p:animEffect>
+                                  </p:childTnLst>
+                                </p:cTn>
+                              </p:par>
+                            </p:childTnLst>
+                          </p:cTn>
+                        </p:par>
+                      </p:childTnLst>
+                    </p:cTn>
+                  </p:par>
+                </p:childTnLst>
+              </p:cTn>
+              <p:prevCondLst>
+                <p:cond evt="onPrev" delay="0">
+                  <p:tgtEl>
+                    <p:sldTgt/>
+                  </p:tgtEl>
+                </p:cond>
+              </p:prevCondLst>
+              <p:nextCondLst>
+                <p:cond evt="onNext" delay="0">
+                  <p:tgtEl>
+                    <p:sldTgt/>
+                  </p:tgtEl>
+                </p:cond>
+              </p:nextCondLst>
+            </p:seq>
+          </p:childTnLst>
+        </p:cTn>
+      </p:par>
+    </p:tnLst>
+  </p:timing>
 </p:sld>
 </file>
 
@@ -10848,6 +11835,139 @@
   <p:clrMapOvr>
     <a:masterClrMapping/>
   </p:clrMapOvr>
+  <mc:AlternateContent xmlns:mc="http://schemas.openxmlformats.org/markup-compatibility/2006">
+    <mc:Choice xmlns:p14="http://schemas.microsoft.com/office/powerpoint/2010/main" Requires="p14">
+      <p:transition spd="med" p14:dur="700">
+        <p:fade/>
+      </p:transition>
+    </mc:Choice>
+    <mc:Fallback>
+      <p:transition spd="med">
+        <p:fade/>
+      </p:transition>
+    </mc:Fallback>
+  </mc:AlternateContent>
+  <p:timing>
+    <p:tnLst>
+      <p:par>
+        <p:cTn id="1" dur="indefinite" restart="never" nodeType="tmRoot">
+          <p:childTnLst>
+            <p:seq concurrent="1" nextAc="seek">
+              <p:cTn id="2" dur="indefinite" nodeType="mainSeq">
+                <p:childTnLst>
+                  <p:par>
+                    <p:cTn id="3" fill="hold">
+                      <p:stCondLst>
+                        <p:cond delay="indefinite"/>
+                        <p:cond evt="onBegin" delay="0">
+                          <p:tn val="2"/>
+                        </p:cond>
+                      </p:stCondLst>
+                      <p:childTnLst>
+                        <p:par>
+                          <p:cTn id="4" fill="hold">
+                            <p:stCondLst>
+                              <p:cond delay="0"/>
+                            </p:stCondLst>
+                            <p:childTnLst>
+                              <p:par>
+                                <p:cTn id="5" presetID="10" presetClass="entr" presetSubtype="0" fill="hold" nodeType="afterEffect">
+                                  <p:stCondLst>
+                                    <p:cond delay="0"/>
+                                  </p:stCondLst>
+                                  <p:childTnLst>
+                                    <p:set>
+                                      <p:cBhvr>
+                                        <p:cTn id="6" dur="1" fill="hold">
+                                          <p:stCondLst>
+                                            <p:cond delay="0"/>
+                                          </p:stCondLst>
+                                        </p:cTn>
+                                        <p:tgtEl>
+                                          <p:spTgt spid="4"/>
+                                        </p:tgtEl>
+                                        <p:attrNameLst>
+                                          <p:attrName>style.visibility</p:attrName>
+                                        </p:attrNameLst>
+                                      </p:cBhvr>
+                                      <p:to>
+                                        <p:strVal val="visible"/>
+                                      </p:to>
+                                    </p:set>
+                                    <p:animEffect transition="in" filter="fade">
+                                      <p:cBhvr>
+                                        <p:cTn id="7" dur="500"/>
+                                        <p:tgtEl>
+                                          <p:spTgt spid="4"/>
+                                        </p:tgtEl>
+                                      </p:cBhvr>
+                                    </p:animEffect>
+                                  </p:childTnLst>
+                                </p:cTn>
+                              </p:par>
+                              <p:par>
+                                <p:cTn id="8" presetID="10" presetClass="entr" presetSubtype="0" fill="hold" nodeType="withEffect">
+                                  <p:stCondLst>
+                                    <p:cond delay="300"/>
+                                  </p:stCondLst>
+                                  <p:childTnLst>
+                                    <p:set>
+                                      <p:cBhvr>
+                                        <p:cTn id="9" dur="1" fill="hold">
+                                          <p:stCondLst>
+                                            <p:cond delay="0"/>
+                                          </p:stCondLst>
+                                        </p:cTn>
+                                        <p:tgtEl>
+                                          <p:spTgt spid="63"/>
+                                        </p:tgtEl>
+                                        <p:attrNameLst>
+                                          <p:attrName>style.visibility</p:attrName>
+                                        </p:attrNameLst>
+                                      </p:cBhvr>
+                                      <p:to>
+                                        <p:strVal val="visible"/>
+                                      </p:to>
+                                    </p:set>
+                                    <p:animEffect transition="in" filter="fade">
+                                      <p:cBhvr>
+                                        <p:cTn id="10" dur="500"/>
+                                        <p:tgtEl>
+                                          <p:spTgt spid="63"/>
+                                        </p:tgtEl>
+                                      </p:cBhvr>
+                                    </p:animEffect>
+                                  </p:childTnLst>
+                                </p:cTn>
+                              </p:par>
+                            </p:childTnLst>
+                          </p:cTn>
+                        </p:par>
+                      </p:childTnLst>
+                    </p:cTn>
+                  </p:par>
+                </p:childTnLst>
+              </p:cTn>
+              <p:prevCondLst>
+                <p:cond evt="onPrev" delay="0">
+                  <p:tgtEl>
+                    <p:sldTgt/>
+                  </p:tgtEl>
+                </p:cond>
+              </p:prevCondLst>
+              <p:nextCondLst>
+                <p:cond evt="onNext" delay="0">
+                  <p:tgtEl>
+                    <p:sldTgt/>
+                  </p:tgtEl>
+                </p:cond>
+              </p:nextCondLst>
+            </p:seq>
+          </p:childTnLst>
+        </p:cTn>
+      </p:par>
+    </p:tnLst>
+  </p:timing>
 </p:sld>
 </file>
 
@@ -12110,6 +13230,139 @@
   <p:clrMapOvr>
     <a:masterClrMapping/>
   </p:clrMapOvr>
+  <mc:AlternateContent xmlns:mc="http://schemas.openxmlformats.org/markup-compatibility/2006">
+    <mc:Choice xmlns:p14="http://schemas.microsoft.com/office/powerpoint/2010/main" Requires="p14">
+      <p:transition spd="med" p14:dur="700">
+        <p:fade/>
+      </p:transition>
+    </mc:Choice>
+    <mc:Fallback>
+      <p:transition spd="med">
+        <p:fade/>
+      </p:transition>
+    </mc:Fallback>
+  </mc:AlternateContent>
+  <p:timing>
+    <p:tnLst>
+      <p:par>
+        <p:cTn id="1" dur="indefinite" restart="never" nodeType="tmRoot">
+          <p:childTnLst>
+            <p:seq concurrent="1" nextAc="seek">
+              <p:cTn id="2" dur="indefinite" nodeType="mainSeq">
+                <p:childTnLst>
+                  <p:par>
+                    <p:cTn id="3" fill="hold">
+                      <p:stCondLst>
+                        <p:cond delay="indefinite"/>
+                        <p:cond evt="onBegin" delay="0">
+                          <p:tn val="2"/>
+                        </p:cond>
+                      </p:stCondLst>
+                      <p:childTnLst>
+                        <p:par>
+                          <p:cTn id="4" fill="hold">
+                            <p:stCondLst>
+                              <p:cond delay="0"/>
+                            </p:stCondLst>
+                            <p:childTnLst>
+                              <p:par>
+                                <p:cTn id="5" presetID="10" presetClass="entr" presetSubtype="0" fill="hold" nodeType="afterEffect">
+                                  <p:stCondLst>
+                                    <p:cond delay="0"/>
+                                  </p:stCondLst>
+                                  <p:childTnLst>
+                                    <p:set>
+                                      <p:cBhvr>
+                                        <p:cTn id="6" dur="1" fill="hold">
+                                          <p:stCondLst>
+                                            <p:cond delay="0"/>
+                                          </p:stCondLst>
+                                        </p:cTn>
+                                        <p:tgtEl>
+                                          <p:spTgt spid="4"/>
+                                        </p:tgtEl>
+                                        <p:attrNameLst>
+                                          <p:attrName>style.visibility</p:attrName>
+                                        </p:attrNameLst>
+                                      </p:cBhvr>
+                                      <p:to>
+                                        <p:strVal val="visible"/>
+                                      </p:to>
+                                    </p:set>
+                                    <p:animEffect transition="in" filter="fade">
+                                      <p:cBhvr>
+                                        <p:cTn id="7" dur="500"/>
+                                        <p:tgtEl>
+                                          <p:spTgt spid="4"/>
+                                        </p:tgtEl>
+                                      </p:cBhvr>
+                                    </p:animEffect>
+                                  </p:childTnLst>
+                                </p:cTn>
+                              </p:par>
+                              <p:par>
+                                <p:cTn id="8" presetID="10" presetClass="entr" presetSubtype="0" fill="hold" nodeType="withEffect">
+                                  <p:stCondLst>
+                                    <p:cond delay="300"/>
+                                  </p:stCondLst>
+                                  <p:childTnLst>
+                                    <p:set>
+                                      <p:cBhvr>
+                                        <p:cTn id="9" dur="1" fill="hold">
+                                          <p:stCondLst>
+                                            <p:cond delay="0"/>
+                                          </p:stCondLst>
+                                        </p:cTn>
+                                        <p:tgtEl>
+                                          <p:spTgt spid="31"/>
+                                        </p:tgtEl>
+                                        <p:attrNameLst>
+                                          <p:attrName>style.visibility</p:attrName>
+                                        </p:attrNameLst>
+                                      </p:cBhvr>
+                                      <p:to>
+                                        <p:strVal val="visible"/>
+                                      </p:to>
+                                    </p:set>
+                                    <p:animEffect transition="in" filter="fade">
+                                      <p:cBhvr>
+                                        <p:cTn id="10" dur="500"/>
+                                        <p:tgtEl>
+                                          <p:spTgt spid="31"/>
+                                        </p:tgtEl>
+                                      </p:cBhvr>
+                                    </p:animEffect>
+                                  </p:childTnLst>
+                                </p:cTn>
+                              </p:par>
+                            </p:childTnLst>
+                          </p:cTn>
+                        </p:par>
+                      </p:childTnLst>
+                    </p:cTn>
+                  </p:par>
+                </p:childTnLst>
+              </p:cTn>
+              <p:prevCondLst>
+                <p:cond evt="onPrev" delay="0">
+                  <p:tgtEl>
+                    <p:sldTgt/>
+                  </p:tgtEl>
+                </p:cond>
+              </p:prevCondLst>
+              <p:nextCondLst>
+                <p:cond evt="onNext" delay="0">
+                  <p:tgtEl>
+                    <p:sldTgt/>
+                  </p:tgtEl>
+                </p:cond>
+              </p:nextCondLst>
+            </p:seq>
+          </p:childTnLst>
+        </p:cTn>
+      </p:par>
+    </p:tnLst>
+  </p:timing>
 </p:sld>
 </file>
 
@@ -13377,6 +14630,244 @@
   <p:clrMapOvr>
     <a:masterClrMapping/>
   </p:clrMapOvr>
+  <mc:AlternateContent xmlns:mc="http://schemas.openxmlformats.org/markup-compatibility/2006">
+    <mc:Choice xmlns:p14="http://schemas.microsoft.com/office/powerpoint/2010/main" Requires="p14">
+      <p:transition spd="med" p14:dur="700">
+        <p:fade/>
+      </p:transition>
+    </mc:Choice>
+    <mc:Fallback>
+      <p:transition spd="med">
+        <p:fade/>
+      </p:transition>
+    </mc:Fallback>
+  </mc:AlternateContent>
+  <p:timing>
+    <p:tnLst>
+      <p:par>
+        <p:cTn id="1" dur="indefinite" restart="never" nodeType="tmRoot">
+          <p:childTnLst>
+            <p:seq concurrent="1" nextAc="seek">
+              <p:cTn id="2" dur="indefinite" nodeType="mainSeq">
+                <p:childTnLst>
+                  <p:par>
+                    <p:cTn id="3" fill="hold">
+                      <p:stCondLst>
+                        <p:cond delay="indefinite"/>
+                        <p:cond evt="onBegin" delay="0">
+                          <p:tn val="2"/>
+                        </p:cond>
+                      </p:stCondLst>
+                      <p:childTnLst>
+                        <p:par>
+                          <p:cTn id="4" fill="hold">
+                            <p:stCondLst>
+                              <p:cond delay="0"/>
+                            </p:stCondLst>
+                            <p:childTnLst>
+                              <p:par>
+                                <p:cTn id="5" presetID="10" presetClass="entr" presetSubtype="0" fill="hold" nodeType="afterEffect">
+                                  <p:stCondLst>
+                                    <p:cond delay="0"/>
+                                  </p:stCondLst>
+                                  <p:childTnLst>
+                                    <p:set>
+                                      <p:cBhvr>
+                                        <p:cTn id="6" dur="1" fill="hold">
+                                          <p:stCondLst>
+                                            <p:cond delay="0"/>
+                                          </p:stCondLst>
+                                        </p:cTn>
+                                        <p:tgtEl>
+                                          <p:spTgt spid="4"/>
+                                        </p:tgtEl>
+                                        <p:attrNameLst>
+                                          <p:attrName>style.visibility</p:attrName>
+                                        </p:attrNameLst>
+                                      </p:cBhvr>
+                                      <p:to>
+                                        <p:strVal val="visible"/>
+                                      </p:to>
+                                    </p:set>
+                                    <p:animEffect transition="in" filter="fade">
+                                      <p:cBhvr>
+                                        <p:cTn id="7" dur="500"/>
+                                        <p:tgtEl>
+                                          <p:spTgt spid="4"/>
+                                        </p:tgtEl>
+                                      </p:cBhvr>
+                                    </p:animEffect>
+                                  </p:childTnLst>
+                                </p:cTn>
+                              </p:par>
+                              <p:par>
+                                <p:cTn id="8" presetID="10" presetClass="entr" presetSubtype="0" fill="hold" nodeType="withEffect">
+                                  <p:stCondLst>
+                                    <p:cond delay="300"/>
+                                  </p:stCondLst>
+                                  <p:childTnLst>
+                                    <p:set>
+                                      <p:cBhvr>
+                                        <p:cTn id="9" dur="1" fill="hold">
+                                          <p:stCondLst>
+                                            <p:cond delay="0"/>
+                                          </p:stCondLst>
+                                        </p:cTn>
+                                        <p:tgtEl>
+                                          <p:spTgt spid="9"/>
+                                        </p:tgtEl>
+                                        <p:attrNameLst>
+                                          <p:attrName>style.visibility</p:attrName>
+                                        </p:attrNameLst>
+                                      </p:cBhvr>
+                                      <p:to>
+                                        <p:strVal val="visible"/>
+                                      </p:to>
+                                    </p:set>
+                                    <p:animEffect transition="in" filter="fade">
+                                      <p:cBhvr>
+                                        <p:cTn id="10" dur="500"/>
+                                        <p:tgtEl>
+                                          <p:spTgt spid="9"/>
+                                        </p:tgtEl>
+                                      </p:cBhvr>
+                                    </p:animEffect>
+                                  </p:childTnLst>
+                                </p:cTn>
+                              </p:par>
+                              <p:par>
+                                <p:cTn id="11" presetID="10" presetClass="entr" presetSubtype="0" fill="hold" nodeType="withEffect">
+                                  <p:stCondLst>
+                                    <p:cond delay="600"/>
+                                  </p:stCondLst>
+                                  <p:childTnLst>
+                                    <p:set>
+                                      <p:cBhvr>
+                                        <p:cTn id="12" dur="1" fill="hold">
+                                          <p:stCondLst>
+                                            <p:cond delay="0"/>
+                                          </p:stCondLst>
+                                        </p:cTn>
+                                        <p:tgtEl>
+                                          <p:spTgt spid="17"/>
+                                        </p:tgtEl>
+                                        <p:attrNameLst>
+                                          <p:attrName>style.visibility</p:attrName>
+                                        </p:attrNameLst>
+                                      </p:cBhvr>
+                                      <p:to>
+                                        <p:strVal val="visible"/>
+                                      </p:to>
+                                    </p:set>
+                                    <p:animEffect transition="in" filter="fade">
+                                      <p:cBhvr>
+                                        <p:cTn id="13" dur="500"/>
+                                        <p:tgtEl>
+                                          <p:spTgt spid="17"/>
+                                        </p:tgtEl>
+                                      </p:cBhvr>
+                                    </p:animEffect>
+                                  </p:childTnLst>
+                                </p:cTn>
+                              </p:par>
+                              <p:par>
+                                <p:cTn id="14" presetID="10" presetClass="entr" presetSubtype="0" fill="hold" nodeType="withEffect">
+                                  <p:stCondLst>
+                                    <p:cond delay="900"/>
+                                  </p:stCondLst>
+                                  <p:childTnLst>
+                                    <p:set>
+                                      <p:cBhvr>
+                                        <p:cTn id="15" dur="1" fill="hold">
+                                          <p:stCondLst>
+                                            <p:cond delay="0"/>
+                                          </p:stCondLst>
+                                        </p:cTn>
+                                        <p:tgtEl>
+                                          <p:spTgt spid="36"/>
+                                        </p:tgtEl>
+                                        <p:attrNameLst>
+                                          <p:attrName>style.visibility</p:attrName>
+                                        </p:attrNameLst>
+                                      </p:cBhvr>
+                                      <p:to>
+                                        <p:strVal val="visible"/>
+                                      </p:to>
+                                    </p:set>
+                                    <p:animEffect transition="in" filter="fade">
+                                      <p:cBhvr>
+                                        <p:cTn id="16" dur="500"/>
+                                        <p:tgtEl>
+                                          <p:spTgt spid="36"/>
+                                        </p:tgtEl>
+                                      </p:cBhvr>
+                                    </p:animEffect>
+                                  </p:childTnLst>
+                                </p:cTn>
+                              </p:par>
+                              <p:par>
+                                <p:cTn id="17" presetID="10" presetClass="entr" presetSubtype="0" fill="hold" nodeType="withEffect">
+                                  <p:stCondLst>
+                                    <p:cond delay="1200"/>
+                                  </p:stCondLst>
+                                  <p:childTnLst>
+                                    <p:set>
+                                      <p:cBhvr>
+                                        <p:cTn id="18" dur="1" fill="hold">
+                                          <p:stCondLst>
+                                            <p:cond delay="0"/>
+                                          </p:stCondLst>
+                                        </p:cTn>
+                                        <p:tgtEl>
+                                          <p:spTgt spid="37"/>
+                                        </p:tgtEl>
+                                        <p:attrNameLst>
+                                          <p:attrName>style.visibility</p:attrName>
+                                        </p:attrNameLst>
+                                      </p:cBhvr>
+                                      <p:to>
+                                        <p:strVal val="visible"/>
+                                      </p:to>
+                                    </p:set>
+                                    <p:animEffect transition="in" filter="fade">
+                                      <p:cBhvr>
+                                        <p:cTn id="19" dur="500"/>
+                                        <p:tgtEl>
+                                          <p:spTgt spid="37"/>
+                                        </p:tgtEl>
+                                      </p:cBhvr>
+                                    </p:animEffect>
+                                  </p:childTnLst>
+                                </p:cTn>
+                              </p:par>
+                            </p:childTnLst>
+                          </p:cTn>
+                        </p:par>
+                      </p:childTnLst>
+                    </p:cTn>
+                  </p:par>
+                </p:childTnLst>
+              </p:cTn>
+              <p:prevCondLst>
+                <p:cond evt="onPrev" delay="0">
+                  <p:tgtEl>
+                    <p:sldTgt/>
+                  </p:tgtEl>
+                </p:cond>
+              </p:prevCondLst>
+              <p:nextCondLst>
+                <p:cond evt="onNext" delay="0">
+                  <p:tgtEl>
+                    <p:sldTgt/>
+                  </p:tgtEl>
+                </p:cond>
+              </p:nextCondLst>
+            </p:seq>
+          </p:childTnLst>
+        </p:cTn>
+      </p:par>
+    </p:tnLst>
+  </p:timing>
 </p:sld>
 </file>
 
@@ -14412,6 +15903,314 @@
   <p:clrMapOvr>
     <a:masterClrMapping/>
   </p:clrMapOvr>
+  <mc:AlternateContent xmlns:mc="http://schemas.openxmlformats.org/markup-compatibility/2006">
+    <mc:Choice xmlns:p14="http://schemas.microsoft.com/office/powerpoint/2010/main" Requires="p14">
+      <p:transition spd="med" p14:dur="700">
+        <p:fade/>
+      </p:transition>
+    </mc:Choice>
+    <mc:Fallback>
+      <p:transition spd="med">
+        <p:fade/>
+      </p:transition>
+    </mc:Fallback>
+  </mc:AlternateContent>
+  <p:timing>
+    <p:tnLst>
+      <p:par>
+        <p:cTn id="1" dur="indefinite" restart="never" nodeType="tmRoot">
+          <p:childTnLst>
+            <p:seq concurrent="1" nextAc="seek">
+              <p:cTn id="2" dur="indefinite" nodeType="mainSeq">
+                <p:childTnLst>
+                  <p:par>
+                    <p:cTn id="3" fill="hold">
+                      <p:stCondLst>
+                        <p:cond delay="indefinite"/>
+                        <p:cond evt="onBegin" delay="0">
+                          <p:tn val="2"/>
+                        </p:cond>
+                      </p:stCondLst>
+                      <p:childTnLst>
+                        <p:par>
+                          <p:cTn id="4" fill="hold">
+                            <p:stCondLst>
+                              <p:cond delay="0"/>
+                            </p:stCondLst>
+                            <p:childTnLst>
+                              <p:par>
+                                <p:cTn id="5" presetID="10" presetClass="entr" presetSubtype="0" fill="hold" nodeType="afterEffect">
+                                  <p:stCondLst>
+                                    <p:cond delay="0"/>
+                                  </p:stCondLst>
+                                  <p:childTnLst>
+                                    <p:set>
+                                      <p:cBhvr>
+                                        <p:cTn id="6" dur="1" fill="hold">
+                                          <p:stCondLst>
+                                            <p:cond delay="0"/>
+                                          </p:stCondLst>
+                                        </p:cTn>
+                                        <p:tgtEl>
+                                          <p:spTgt spid="4"/>
+                                        </p:tgtEl>
+                                        <p:attrNameLst>
+                                          <p:attrName>style.visibility</p:attrName>
+                                        </p:attrNameLst>
+                                      </p:cBhvr>
+                                      <p:to>
+                                        <p:strVal val="visible"/>
+                                      </p:to>
+                                    </p:set>
+                                    <p:animEffect transition="in" filter="fade">
+                                      <p:cBhvr>
+                                        <p:cTn id="7" dur="500"/>
+                                        <p:tgtEl>
+                                          <p:spTgt spid="4"/>
+                                        </p:tgtEl>
+                                      </p:cBhvr>
+                                    </p:animEffect>
+                                  </p:childTnLst>
+                                </p:cTn>
+                              </p:par>
+                              <p:par>
+                                <p:cTn id="8" presetID="10" presetClass="entr" presetSubtype="0" fill="hold" nodeType="withEffect">
+                                  <p:stCondLst>
+                                    <p:cond delay="257"/>
+                                  </p:stCondLst>
+                                  <p:childTnLst>
+                                    <p:set>
+                                      <p:cBhvr>
+                                        <p:cTn id="9" dur="1" fill="hold">
+                                          <p:stCondLst>
+                                            <p:cond delay="0"/>
+                                          </p:stCondLst>
+                                        </p:cTn>
+                                        <p:tgtEl>
+                                          <p:spTgt spid="10"/>
+                                        </p:tgtEl>
+                                        <p:attrNameLst>
+                                          <p:attrName>style.visibility</p:attrName>
+                                        </p:attrNameLst>
+                                      </p:cBhvr>
+                                      <p:to>
+                                        <p:strVal val="visible"/>
+                                      </p:to>
+                                    </p:set>
+                                    <p:animEffect transition="in" filter="fade">
+                                      <p:cBhvr>
+                                        <p:cTn id="10" dur="500"/>
+                                        <p:tgtEl>
+                                          <p:spTgt spid="10"/>
+                                        </p:tgtEl>
+                                      </p:cBhvr>
+                                    </p:animEffect>
+                                  </p:childTnLst>
+                                </p:cTn>
+                              </p:par>
+                              <p:par>
+                                <p:cTn id="11" presetID="10" presetClass="entr" presetSubtype="0" fill="hold" nodeType="withEffect">
+                                  <p:stCondLst>
+                                    <p:cond delay="514"/>
+                                  </p:stCondLst>
+                                  <p:childTnLst>
+                                    <p:set>
+                                      <p:cBhvr>
+                                        <p:cTn id="12" dur="1" fill="hold">
+                                          <p:stCondLst>
+                                            <p:cond delay="0"/>
+                                          </p:stCondLst>
+                                        </p:cTn>
+                                        <p:tgtEl>
+                                          <p:spTgt spid="14"/>
+                                        </p:tgtEl>
+                                        <p:attrNameLst>
+                                          <p:attrName>style.visibility</p:attrName>
+                                        </p:attrNameLst>
+                                      </p:cBhvr>
+                                      <p:to>
+                                        <p:strVal val="visible"/>
+                                      </p:to>
+                                    </p:set>
+                                    <p:animEffect transition="in" filter="fade">
+                                      <p:cBhvr>
+                                        <p:cTn id="13" dur="500"/>
+                                        <p:tgtEl>
+                                          <p:spTgt spid="14"/>
+                                        </p:tgtEl>
+                                      </p:cBhvr>
+                                    </p:animEffect>
+                                  </p:childTnLst>
+                                </p:cTn>
+                              </p:par>
+                              <p:par>
+                                <p:cTn id="14" presetID="10" presetClass="entr" presetSubtype="0" fill="hold" nodeType="withEffect">
+                                  <p:stCondLst>
+                                    <p:cond delay="771"/>
+                                  </p:stCondLst>
+                                  <p:childTnLst>
+                                    <p:set>
+                                      <p:cBhvr>
+                                        <p:cTn id="15" dur="1" fill="hold">
+                                          <p:stCondLst>
+                                            <p:cond delay="0"/>
+                                          </p:stCondLst>
+                                        </p:cTn>
+                                        <p:tgtEl>
+                                          <p:spTgt spid="18"/>
+                                        </p:tgtEl>
+                                        <p:attrNameLst>
+                                          <p:attrName>style.visibility</p:attrName>
+                                        </p:attrNameLst>
+                                      </p:cBhvr>
+                                      <p:to>
+                                        <p:strVal val="visible"/>
+                                      </p:to>
+                                    </p:set>
+                                    <p:animEffect transition="in" filter="fade">
+                                      <p:cBhvr>
+                                        <p:cTn id="16" dur="500"/>
+                                        <p:tgtEl>
+                                          <p:spTgt spid="18"/>
+                                        </p:tgtEl>
+                                      </p:cBhvr>
+                                    </p:animEffect>
+                                  </p:childTnLst>
+                                </p:cTn>
+                              </p:par>
+                              <p:par>
+                                <p:cTn id="17" presetID="10" presetClass="entr" presetSubtype="0" fill="hold" nodeType="withEffect">
+                                  <p:stCondLst>
+                                    <p:cond delay="1028"/>
+                                  </p:stCondLst>
+                                  <p:childTnLst>
+                                    <p:set>
+                                      <p:cBhvr>
+                                        <p:cTn id="18" dur="1" fill="hold">
+                                          <p:stCondLst>
+                                            <p:cond delay="0"/>
+                                          </p:stCondLst>
+                                        </p:cTn>
+                                        <p:tgtEl>
+                                          <p:spTgt spid="22"/>
+                                        </p:tgtEl>
+                                        <p:attrNameLst>
+                                          <p:attrName>style.visibility</p:attrName>
+                                        </p:attrNameLst>
+                                      </p:cBhvr>
+                                      <p:to>
+                                        <p:strVal val="visible"/>
+                                      </p:to>
+                                    </p:set>
+                                    <p:animEffect transition="in" filter="fade">
+                                      <p:cBhvr>
+                                        <p:cTn id="19" dur="500"/>
+                                        <p:tgtEl>
+                                          <p:spTgt spid="22"/>
+                                        </p:tgtEl>
+                                      </p:cBhvr>
+                                    </p:animEffect>
+                                  </p:childTnLst>
+                                </p:cTn>
+                              </p:par>
+                              <p:par>
+                                <p:cTn id="20" presetID="10" presetClass="entr" presetSubtype="0" fill="hold" nodeType="withEffect">
+                                  <p:stCondLst>
+                                    <p:cond delay="1285"/>
+                                  </p:stCondLst>
+                                  <p:childTnLst>
+                                    <p:set>
+                                      <p:cBhvr>
+                                        <p:cTn id="21" dur="1" fill="hold">
+                                          <p:stCondLst>
+                                            <p:cond delay="0"/>
+                                          </p:stCondLst>
+                                        </p:cTn>
+                                        <p:tgtEl>
+                                          <p:spTgt spid="26"/>
+                                        </p:tgtEl>
+                                        <p:attrNameLst>
+                                          <p:attrName>style.visibility</p:attrName>
+                                        </p:attrNameLst>
+                                      </p:cBhvr>
+                                      <p:to>
+                                        <p:strVal val="visible"/>
+                                      </p:to>
+                                    </p:set>
+                                    <p:animEffect transition="in" filter="fade">
+                                      <p:cBhvr>
+                                        <p:cTn id="22" dur="500"/>
+                                        <p:tgtEl>
+                                          <p:spTgt spid="26"/>
+                                        </p:tgtEl>
+                                      </p:cBhvr>
+                                    </p:animEffect>
+                                  </p:childTnLst>
+                                </p:cTn>
+                              </p:par>
+                              <p:par>
+                                <p:cTn id="23" presetID="10" presetClass="entr" presetSubtype="0" fill="hold" nodeType="withEffect">
+                                  <p:stCondLst>
+                                    <p:cond delay="1542"/>
+                                  </p:stCondLst>
+                                  <p:childTnLst>
+                                    <p:set>
+                                      <p:cBhvr>
+                                        <p:cTn id="24" dur="1" fill="hold">
+                                          <p:stCondLst>
+                                            <p:cond delay="0"/>
+                                          </p:stCondLst>
+                                        </p:cTn>
+                                        <p:tgtEl>
+                                          <p:spTgt spid="27"/>
+                                        </p:tgtEl>
+                                        <p:attrNameLst>
+                                          <p:attrName>style.visibility</p:attrName>
+                                        </p:attrNameLst>
+                                      </p:cBhvr>
+                                      <p:to>
+                                        <p:strVal val="visible"/>
+                                      </p:to>
+                                    </p:set>
+                                    <p:animEffect transition="in" filter="fade">
+                                      <p:cBhvr>
+                                        <p:cTn id="25" dur="500"/>
+                                        <p:tgtEl>
+                                          <p:spTgt spid="27"/>
+                                        </p:tgtEl>
+                                      </p:cBhvr>
+                                    </p:animEffect>
+                                  </p:childTnLst>
+                                </p:cTn>
+                              </p:par>
+                            </p:childTnLst>
+                          </p:cTn>
+                        </p:par>
+                      </p:childTnLst>
+                    </p:cTn>
+                  </p:par>
+                </p:childTnLst>
+              </p:cTn>
+              <p:prevCondLst>
+                <p:cond evt="onPrev" delay="0">
+                  <p:tgtEl>
+                    <p:sldTgt/>
+                  </p:tgtEl>
+                </p:cond>
+              </p:prevCondLst>
+              <p:nextCondLst>
+                <p:cond evt="onNext" delay="0">
+                  <p:tgtEl>
+                    <p:sldTgt/>
+                  </p:tgtEl>
+                </p:cond>
+              </p:nextCondLst>
+            </p:seq>
+          </p:childTnLst>
+        </p:cTn>
+      </p:par>
+    </p:tnLst>
+  </p:timing>
 </p:sld>
 </file>
 
@@ -15856,6 +17655,384 @@
   <p:clrMapOvr>
     <a:masterClrMapping/>
   </p:clrMapOvr>
+  <mc:AlternateContent xmlns:mc="http://schemas.openxmlformats.org/markup-compatibility/2006">
+    <mc:Choice xmlns:p14="http://schemas.microsoft.com/office/powerpoint/2010/main" Requires="p14">
+      <p:transition spd="med" p14:dur="700">
+        <p:fade/>
+      </p:transition>
+    </mc:Choice>
+    <mc:Fallback>
+      <p:transition spd="med">
+        <p:fade/>
+      </p:transition>
+    </mc:Fallback>
+  </mc:AlternateContent>
+  <p:timing>
+    <p:tnLst>
+      <p:par>
+        <p:cTn id="1" dur="indefinite" restart="never" nodeType="tmRoot">
+          <p:childTnLst>
+            <p:seq concurrent="1" nextAc="seek">
+              <p:cTn id="2" dur="indefinite" nodeType="mainSeq">
+                <p:childTnLst>
+                  <p:par>
+                    <p:cTn id="3" fill="hold">
+                      <p:stCondLst>
+                        <p:cond delay="indefinite"/>
+                        <p:cond evt="onBegin" delay="0">
+                          <p:tn val="2"/>
+                        </p:cond>
+                      </p:stCondLst>
+                      <p:childTnLst>
+                        <p:par>
+                          <p:cTn id="4" fill="hold">
+                            <p:stCondLst>
+                              <p:cond delay="0"/>
+                            </p:stCondLst>
+                            <p:childTnLst>
+                              <p:par>
+                                <p:cTn id="5" presetID="10" presetClass="entr" presetSubtype="0" fill="hold" nodeType="afterEffect">
+                                  <p:stCondLst>
+                                    <p:cond delay="0"/>
+                                  </p:stCondLst>
+                                  <p:childTnLst>
+                                    <p:set>
+                                      <p:cBhvr>
+                                        <p:cTn id="6" dur="1" fill="hold">
+                                          <p:stCondLst>
+                                            <p:cond delay="0"/>
+                                          </p:stCondLst>
+                                        </p:cTn>
+                                        <p:tgtEl>
+                                          <p:spTgt spid="4"/>
+                                        </p:tgtEl>
+                                        <p:attrNameLst>
+                                          <p:attrName>style.visibility</p:attrName>
+                                        </p:attrNameLst>
+                                      </p:cBhvr>
+                                      <p:to>
+                                        <p:strVal val="visible"/>
+                                      </p:to>
+                                    </p:set>
+                                    <p:animEffect transition="in" filter="fade">
+                                      <p:cBhvr>
+                                        <p:cTn id="7" dur="500"/>
+                                        <p:tgtEl>
+                                          <p:spTgt spid="4"/>
+                                        </p:tgtEl>
+                                      </p:cBhvr>
+                                    </p:animEffect>
+                                  </p:childTnLst>
+                                </p:cTn>
+                              </p:par>
+                              <p:par>
+                                <p:cTn id="8" presetID="10" presetClass="entr" presetSubtype="0" fill="hold" nodeType="withEffect">
+                                  <p:stCondLst>
+                                    <p:cond delay="200"/>
+                                  </p:stCondLst>
+                                  <p:childTnLst>
+                                    <p:set>
+                                      <p:cBhvr>
+                                        <p:cTn id="9" dur="1" fill="hold">
+                                          <p:stCondLst>
+                                            <p:cond delay="0"/>
+                                          </p:stCondLst>
+                                        </p:cTn>
+                                        <p:tgtEl>
+                                          <p:spTgt spid="8"/>
+                                        </p:tgtEl>
+                                        <p:attrNameLst>
+                                          <p:attrName>style.visibility</p:attrName>
+                                        </p:attrNameLst>
+                                      </p:cBhvr>
+                                      <p:to>
+                                        <p:strVal val="visible"/>
+                                      </p:to>
+                                    </p:set>
+                                    <p:animEffect transition="in" filter="fade">
+                                      <p:cBhvr>
+                                        <p:cTn id="10" dur="500"/>
+                                        <p:tgtEl>
+                                          <p:spTgt spid="8"/>
+                                        </p:tgtEl>
+                                      </p:cBhvr>
+                                    </p:animEffect>
+                                  </p:childTnLst>
+                                </p:cTn>
+                              </p:par>
+                              <p:par>
+                                <p:cTn id="11" presetID="10" presetClass="entr" presetSubtype="0" fill="hold" nodeType="withEffect">
+                                  <p:stCondLst>
+                                    <p:cond delay="400"/>
+                                  </p:stCondLst>
+                                  <p:childTnLst>
+                                    <p:set>
+                                      <p:cBhvr>
+                                        <p:cTn id="12" dur="1" fill="hold">
+                                          <p:stCondLst>
+                                            <p:cond delay="0"/>
+                                          </p:stCondLst>
+                                        </p:cTn>
+                                        <p:tgtEl>
+                                          <p:spTgt spid="12"/>
+                                        </p:tgtEl>
+                                        <p:attrNameLst>
+                                          <p:attrName>style.visibility</p:attrName>
+                                        </p:attrNameLst>
+                                      </p:cBhvr>
+                                      <p:to>
+                                        <p:strVal val="visible"/>
+                                      </p:to>
+                                    </p:set>
+                                    <p:animEffect transition="in" filter="fade">
+                                      <p:cBhvr>
+                                        <p:cTn id="13" dur="500"/>
+                                        <p:tgtEl>
+                                          <p:spTgt spid="12"/>
+                                        </p:tgtEl>
+                                      </p:cBhvr>
+                                    </p:animEffect>
+                                  </p:childTnLst>
+                                </p:cTn>
+                              </p:par>
+                              <p:par>
+                                <p:cTn id="14" presetID="10" presetClass="entr" presetSubtype="0" fill="hold" nodeType="withEffect">
+                                  <p:stCondLst>
+                                    <p:cond delay="600"/>
+                                  </p:stCondLst>
+                                  <p:childTnLst>
+                                    <p:set>
+                                      <p:cBhvr>
+                                        <p:cTn id="15" dur="1" fill="hold">
+                                          <p:stCondLst>
+                                            <p:cond delay="0"/>
+                                          </p:stCondLst>
+                                        </p:cTn>
+                                        <p:tgtEl>
+                                          <p:spTgt spid="16"/>
+                                        </p:tgtEl>
+                                        <p:attrNameLst>
+                                          <p:attrName>style.visibility</p:attrName>
+                                        </p:attrNameLst>
+                                      </p:cBhvr>
+                                      <p:to>
+                                        <p:strVal val="visible"/>
+                                      </p:to>
+                                    </p:set>
+                                    <p:animEffect transition="in" filter="fade">
+                                      <p:cBhvr>
+                                        <p:cTn id="16" dur="500"/>
+                                        <p:tgtEl>
+                                          <p:spTgt spid="16"/>
+                                        </p:tgtEl>
+                                      </p:cBhvr>
+                                    </p:animEffect>
+                                  </p:childTnLst>
+                                </p:cTn>
+                              </p:par>
+                              <p:par>
+                                <p:cTn id="17" presetID="10" presetClass="entr" presetSubtype="0" fill="hold" nodeType="withEffect">
+                                  <p:stCondLst>
+                                    <p:cond delay="800"/>
+                                  </p:stCondLst>
+                                  <p:childTnLst>
+                                    <p:set>
+                                      <p:cBhvr>
+                                        <p:cTn id="18" dur="1" fill="hold">
+                                          <p:stCondLst>
+                                            <p:cond delay="0"/>
+                                          </p:stCondLst>
+                                        </p:cTn>
+                                        <p:tgtEl>
+                                          <p:spTgt spid="20"/>
+                                        </p:tgtEl>
+                                        <p:attrNameLst>
+                                          <p:attrName>style.visibility</p:attrName>
+                                        </p:attrNameLst>
+                                      </p:cBhvr>
+                                      <p:to>
+                                        <p:strVal val="visible"/>
+                                      </p:to>
+                                    </p:set>
+                                    <p:animEffect transition="in" filter="fade">
+                                      <p:cBhvr>
+                                        <p:cTn id="19" dur="500"/>
+                                        <p:tgtEl>
+                                          <p:spTgt spid="20"/>
+                                        </p:tgtEl>
+                                      </p:cBhvr>
+                                    </p:animEffect>
+                                  </p:childTnLst>
+                                </p:cTn>
+                              </p:par>
+                              <p:par>
+                                <p:cTn id="20" presetID="10" presetClass="entr" presetSubtype="0" fill="hold" nodeType="withEffect">
+                                  <p:stCondLst>
+                                    <p:cond delay="1000"/>
+                                  </p:stCondLst>
+                                  <p:childTnLst>
+                                    <p:set>
+                                      <p:cBhvr>
+                                        <p:cTn id="21" dur="1" fill="hold">
+                                          <p:stCondLst>
+                                            <p:cond delay="0"/>
+                                          </p:stCondLst>
+                                        </p:cTn>
+                                        <p:tgtEl>
+                                          <p:spTgt spid="24"/>
+                                        </p:tgtEl>
+                                        <p:attrNameLst>
+                                          <p:attrName>style.visibility</p:attrName>
+                                        </p:attrNameLst>
+                                      </p:cBhvr>
+                                      <p:to>
+                                        <p:strVal val="visible"/>
+                                      </p:to>
+                                    </p:set>
+                                    <p:animEffect transition="in" filter="fade">
+                                      <p:cBhvr>
+                                        <p:cTn id="22" dur="500"/>
+                                        <p:tgtEl>
+                                          <p:spTgt spid="24"/>
+                                        </p:tgtEl>
+                                      </p:cBhvr>
+                                    </p:animEffect>
+                                  </p:childTnLst>
+                                </p:cTn>
+                              </p:par>
+                              <p:par>
+                                <p:cTn id="23" presetID="10" presetClass="entr" presetSubtype="0" fill="hold" nodeType="withEffect">
+                                  <p:stCondLst>
+                                    <p:cond delay="1200"/>
+                                  </p:stCondLst>
+                                  <p:childTnLst>
+                                    <p:set>
+                                      <p:cBhvr>
+                                        <p:cTn id="24" dur="1" fill="hold">
+                                          <p:stCondLst>
+                                            <p:cond delay="0"/>
+                                          </p:stCondLst>
+                                        </p:cTn>
+                                        <p:tgtEl>
+                                          <p:spTgt spid="28"/>
+                                        </p:tgtEl>
+                                        <p:attrNameLst>
+                                          <p:attrName>style.visibility</p:attrName>
+                                        </p:attrNameLst>
+                                      </p:cBhvr>
+                                      <p:to>
+                                        <p:strVal val="visible"/>
+                                      </p:to>
+                                    </p:set>
+                                    <p:animEffect transition="in" filter="fade">
+                                      <p:cBhvr>
+                                        <p:cTn id="25" dur="500"/>
+                                        <p:tgtEl>
+                                          <p:spTgt spid="28"/>
+                                        </p:tgtEl>
+                                      </p:cBhvr>
+                                    </p:animEffect>
+                                  </p:childTnLst>
+                                </p:cTn>
+                              </p:par>
+                              <p:par>
+                                <p:cTn id="26" presetID="10" presetClass="entr" presetSubtype="0" fill="hold" nodeType="withEffect">
+                                  <p:stCondLst>
+                                    <p:cond delay="1400"/>
+                                  </p:stCondLst>
+                                  <p:childTnLst>
+                                    <p:set>
+                                      <p:cBhvr>
+                                        <p:cTn id="27" dur="1" fill="hold">
+                                          <p:stCondLst>
+                                            <p:cond delay="0"/>
+                                          </p:stCondLst>
+                                        </p:cTn>
+                                        <p:tgtEl>
+                                          <p:spTgt spid="32"/>
+                                        </p:tgtEl>
+                                        <p:attrNameLst>
+                                          <p:attrName>style.visibility</p:attrName>
+                                        </p:attrNameLst>
+                                      </p:cBhvr>
+                                      <p:to>
+                                        <p:strVal val="visible"/>
+                                      </p:to>
+                                    </p:set>
+                                    <p:animEffect transition="in" filter="fade">
+                                      <p:cBhvr>
+                                        <p:cTn id="28" dur="500"/>
+                                        <p:tgtEl>
+                                          <p:spTgt spid="32"/>
+                                        </p:tgtEl>
+                                      </p:cBhvr>
+                                    </p:animEffect>
+                                  </p:childTnLst>
+                                </p:cTn>
+                              </p:par>
+                              <p:par>
+                                <p:cTn id="29" presetID="10" presetClass="entr" presetSubtype="0" fill="hold" nodeType="withEffect">
+                                  <p:stCondLst>
+                                    <p:cond delay="1600"/>
+                                  </p:stCondLst>
+                                  <p:childTnLst>
+                                    <p:set>
+                                      <p:cBhvr>
+                                        <p:cTn id="30" dur="1" fill="hold">
+                                          <p:stCondLst>
+                                            <p:cond delay="0"/>
+                                          </p:stCondLst>
+                                        </p:cTn>
+                                        <p:tgtEl>
+                                          <p:spTgt spid="36"/>
+                                        </p:tgtEl>
+                                        <p:attrNameLst>
+                                          <p:attrName>style.visibility</p:attrName>
+                                        </p:attrNameLst>
+                                      </p:cBhvr>
+                                      <p:to>
+                                        <p:strVal val="visible"/>
+                                      </p:to>
+                                    </p:set>
+                                    <p:animEffect transition="in" filter="fade">
+                                      <p:cBhvr>
+                                        <p:cTn id="31" dur="500"/>
+                                        <p:tgtEl>
+                                          <p:spTgt spid="36"/>
+                                        </p:tgtEl>
+                                      </p:cBhvr>
+                                    </p:animEffect>
+                                  </p:childTnLst>
+                                </p:cTn>
+                              </p:par>
+                            </p:childTnLst>
+                          </p:cTn>
+                        </p:par>
+                      </p:childTnLst>
+                    </p:cTn>
+                  </p:par>
+                </p:childTnLst>
+              </p:cTn>
+              <p:prevCondLst>
+                <p:cond evt="onPrev" delay="0">
+                  <p:tgtEl>
+                    <p:sldTgt/>
+                  </p:tgtEl>
+                </p:cond>
+              </p:prevCondLst>
+              <p:nextCondLst>
+                <p:cond evt="onNext" delay="0">
+                  <p:tgtEl>
+                    <p:sldTgt/>
+                  </p:tgtEl>
+                </p:cond>
+              </p:nextCondLst>
+            </p:seq>
+          </p:childTnLst>
+        </p:cTn>
+      </p:par>
+    </p:tnLst>
+  </p:timing>
 </p:sld>
 </file>
 
@@ -16371,6 +18548,104 @@
   <p:clrMapOvr>
     <a:masterClrMapping/>
   </p:clrMapOvr>
+  <mc:AlternateContent xmlns:mc="http://schemas.openxmlformats.org/markup-compatibility/2006">
+    <mc:Choice xmlns:p14="http://schemas.microsoft.com/office/powerpoint/2010/main" Requires="p14">
+      <p:transition spd="med" p14:dur="700">
+        <p:fade/>
+      </p:transition>
+    </mc:Choice>
+    <mc:Fallback>
+      <p:transition spd="med">
+        <p:fade/>
+      </p:transition>
+    </mc:Fallback>
+  </mc:AlternateContent>
+  <p:timing>
+    <p:tnLst>
+      <p:par>
+        <p:cTn id="1" dur="indefinite" restart="never" nodeType="tmRoot">
+          <p:childTnLst>
+            <p:seq concurrent="1" nextAc="seek">
+              <p:cTn id="2" dur="indefinite" nodeType="mainSeq">
+                <p:childTnLst>
+                  <p:par>
+                    <p:cTn id="3" fill="hold">
+                      <p:stCondLst>
+                        <p:cond delay="indefinite"/>
+                        <p:cond evt="onBegin" delay="0">
+                          <p:tn val="2"/>
+                        </p:cond>
+                      </p:stCondLst>
+                      <p:childTnLst>
+                        <p:par>
+                          <p:cTn id="4" fill="hold">
+                            <p:stCondLst>
+                              <p:cond delay="0"/>
+                            </p:stCondLst>
+                            <p:childTnLst>
+                              <p:par>
+                                <p:cTn id="5" presetID="10" presetClass="entr" presetSubtype="0" fill="hold" nodeType="afterEffect">
+                                  <p:stCondLst>
+                                    <p:cond delay="0"/>
+                                  </p:stCondLst>
+                                  <p:childTnLst>
+                                    <p:set>
+                                      <p:cBhvr>
+                                        <p:cTn id="6" dur="1" fill="hold">
+                                          <p:stCondLst>
+                                            <p:cond delay="0"/>
+                                          </p:stCondLst>
+                                        </p:cTn>
+                                        <p:tgtEl>
+                                          <p:spTgt spid="4"/>
+                                        </p:tgtEl>
+                                        <p:attrNameLst>
+                                          <p:attrName>style.visibility</p:attrName>
+                                        </p:attrNameLst>
+                                      </p:cBhvr>
+                                      <p:to>
+                                        <p:strVal val="visible"/>
+                                      </p:to>
+                                    </p:set>
+                                    <p:animEffect transition="in" filter="fade">
+                                      <p:cBhvr>
+                                        <p:cTn id="7" dur="500"/>
+                                        <p:tgtEl>
+                                          <p:spTgt spid="4"/>
+                                        </p:tgtEl>
+                                      </p:cBhvr>
+                                    </p:animEffect>
+                                  </p:childTnLst>
+                                </p:cTn>
+                              </p:par>
+                            </p:childTnLst>
+                          </p:cTn>
+                        </p:par>
+                      </p:childTnLst>
+                    </p:cTn>
+                  </p:par>
+                </p:childTnLst>
+              </p:cTn>
+              <p:prevCondLst>
+                <p:cond evt="onPrev" delay="0">
+                  <p:tgtEl>
+                    <p:sldTgt/>
+                  </p:tgtEl>
+                </p:cond>
+              </p:prevCondLst>
+              <p:nextCondLst>
+                <p:cond evt="onNext" delay="0">
+                  <p:tgtEl>
+                    <p:sldTgt/>
+                  </p:tgtEl>
+                </p:cond>
+              </p:nextCondLst>
+            </p:seq>
+          </p:childTnLst>
+        </p:cTn>
+      </p:par>
+    </p:tnLst>
+  </p:timing>
 </p:sld>
 </file>
 
@@ -17283,6 +19558,279 @@
   <p:clrMapOvr>
     <a:masterClrMapping/>
   </p:clrMapOvr>
+  <mc:AlternateContent xmlns:mc="http://schemas.openxmlformats.org/markup-compatibility/2006">
+    <mc:Choice xmlns:p14="http://schemas.microsoft.com/office/powerpoint/2010/main" Requires="p14">
+      <p:transition spd="med" p14:dur="700">
+        <p:fade/>
+      </p:transition>
+    </mc:Choice>
+    <mc:Fallback>
+      <p:transition spd="med">
+        <p:fade/>
+      </p:transition>
+    </mc:Fallback>
+  </mc:AlternateContent>
+  <p:timing>
+    <p:tnLst>
+      <p:par>
+        <p:cTn id="1" dur="indefinite" restart="never" nodeType="tmRoot">
+          <p:childTnLst>
+            <p:seq concurrent="1" nextAc="seek">
+              <p:cTn id="2" dur="indefinite" nodeType="mainSeq">
+                <p:childTnLst>
+                  <p:par>
+                    <p:cTn id="3" fill="hold">
+                      <p:stCondLst>
+                        <p:cond delay="indefinite"/>
+                        <p:cond evt="onBegin" delay="0">
+                          <p:tn val="2"/>
+                        </p:cond>
+                      </p:stCondLst>
+                      <p:childTnLst>
+                        <p:par>
+                          <p:cTn id="4" fill="hold">
+                            <p:stCondLst>
+                              <p:cond delay="0"/>
+                            </p:stCondLst>
+                            <p:childTnLst>
+                              <p:par>
+                                <p:cTn id="5" presetID="10" presetClass="entr" presetSubtype="0" fill="hold" nodeType="afterEffect">
+                                  <p:stCondLst>
+                                    <p:cond delay="0"/>
+                                  </p:stCondLst>
+                                  <p:childTnLst>
+                                    <p:set>
+                                      <p:cBhvr>
+                                        <p:cTn id="6" dur="1" fill="hold">
+                                          <p:stCondLst>
+                                            <p:cond delay="0"/>
+                                          </p:stCondLst>
+                                        </p:cTn>
+                                        <p:tgtEl>
+                                          <p:spTgt spid="3"/>
+                                        </p:tgtEl>
+                                        <p:attrNameLst>
+                                          <p:attrName>style.visibility</p:attrName>
+                                        </p:attrNameLst>
+                                      </p:cBhvr>
+                                      <p:to>
+                                        <p:strVal val="visible"/>
+                                      </p:to>
+                                    </p:set>
+                                    <p:animEffect transition="in" filter="fade">
+                                      <p:cBhvr>
+                                        <p:cTn id="7" dur="500"/>
+                                        <p:tgtEl>
+                                          <p:spTgt spid="3"/>
+                                        </p:tgtEl>
+                                      </p:cBhvr>
+                                    </p:animEffect>
+                                  </p:childTnLst>
+                                </p:cTn>
+                              </p:par>
+                              <p:par>
+                                <p:cTn id="8" presetID="10" presetClass="entr" presetSubtype="0" fill="hold" nodeType="withEffect">
+                                  <p:stCondLst>
+                                    <p:cond delay="300"/>
+                                  </p:stCondLst>
+                                  <p:childTnLst>
+                                    <p:set>
+                                      <p:cBhvr>
+                                        <p:cTn id="9" dur="1" fill="hold">
+                                          <p:stCondLst>
+                                            <p:cond delay="0"/>
+                                          </p:stCondLst>
+                                        </p:cTn>
+                                        <p:tgtEl>
+                                          <p:spTgt spid="7"/>
+                                        </p:tgtEl>
+                                        <p:attrNameLst>
+                                          <p:attrName>style.visibility</p:attrName>
+                                        </p:attrNameLst>
+                                      </p:cBhvr>
+                                      <p:to>
+                                        <p:strVal val="visible"/>
+                                      </p:to>
+                                    </p:set>
+                                    <p:animEffect transition="in" filter="fade">
+                                      <p:cBhvr>
+                                        <p:cTn id="10" dur="500"/>
+                                        <p:tgtEl>
+                                          <p:spTgt spid="7"/>
+                                        </p:tgtEl>
+                                      </p:cBhvr>
+                                    </p:animEffect>
+                                  </p:childTnLst>
+                                </p:cTn>
+                              </p:par>
+                              <p:par>
+                                <p:cTn id="11" presetID="10" presetClass="entr" presetSubtype="0" fill="hold" nodeType="withEffect">
+                                  <p:stCondLst>
+                                    <p:cond delay="600"/>
+                                  </p:stCondLst>
+                                  <p:childTnLst>
+                                    <p:set>
+                                      <p:cBhvr>
+                                        <p:cTn id="12" dur="1" fill="hold">
+                                          <p:stCondLst>
+                                            <p:cond delay="0"/>
+                                          </p:stCondLst>
+                                        </p:cTn>
+                                        <p:tgtEl>
+                                          <p:spTgt spid="11"/>
+                                        </p:tgtEl>
+                                        <p:attrNameLst>
+                                          <p:attrName>style.visibility</p:attrName>
+                                        </p:attrNameLst>
+                                      </p:cBhvr>
+                                      <p:to>
+                                        <p:strVal val="visible"/>
+                                      </p:to>
+                                    </p:set>
+                                    <p:animEffect transition="in" filter="fade">
+                                      <p:cBhvr>
+                                        <p:cTn id="13" dur="500"/>
+                                        <p:tgtEl>
+                                          <p:spTgt spid="11"/>
+                                        </p:tgtEl>
+                                      </p:cBhvr>
+                                    </p:animEffect>
+                                  </p:childTnLst>
+                                </p:cTn>
+                              </p:par>
+                              <p:par>
+                                <p:cTn id="14" presetID="10" presetClass="entr" presetSubtype="0" fill="hold" nodeType="withEffect">
+                                  <p:stCondLst>
+                                    <p:cond delay="900"/>
+                                  </p:stCondLst>
+                                  <p:childTnLst>
+                                    <p:set>
+                                      <p:cBhvr>
+                                        <p:cTn id="15" dur="1" fill="hold">
+                                          <p:stCondLst>
+                                            <p:cond delay="0"/>
+                                          </p:stCondLst>
+                                        </p:cTn>
+                                        <p:tgtEl>
+                                          <p:spTgt spid="15"/>
+                                        </p:tgtEl>
+                                        <p:attrNameLst>
+                                          <p:attrName>style.visibility</p:attrName>
+                                        </p:attrNameLst>
+                                      </p:cBhvr>
+                                      <p:to>
+                                        <p:strVal val="visible"/>
+                                      </p:to>
+                                    </p:set>
+                                    <p:animEffect transition="in" filter="fade">
+                                      <p:cBhvr>
+                                        <p:cTn id="16" dur="500"/>
+                                        <p:tgtEl>
+                                          <p:spTgt spid="15"/>
+                                        </p:tgtEl>
+                                      </p:cBhvr>
+                                    </p:animEffect>
+                                  </p:childTnLst>
+                                </p:cTn>
+                              </p:par>
+                              <p:par>
+                                <p:cTn id="17" presetID="10" presetClass="entr" presetSubtype="0" fill="hold" nodeType="withEffect">
+                                  <p:stCondLst>
+                                    <p:cond delay="1200"/>
+                                  </p:stCondLst>
+                                  <p:childTnLst>
+                                    <p:set>
+                                      <p:cBhvr>
+                                        <p:cTn id="18" dur="1" fill="hold">
+                                          <p:stCondLst>
+                                            <p:cond delay="0"/>
+                                          </p:stCondLst>
+                                        </p:cTn>
+                                        <p:tgtEl>
+                                          <p:spTgt spid="19"/>
+                                        </p:tgtEl>
+                                        <p:attrNameLst>
+                                          <p:attrName>style.visibility</p:attrName>
+                                        </p:attrNameLst>
+                                      </p:cBhvr>
+                                      <p:to>
+                                        <p:strVal val="visible"/>
+                                      </p:to>
+                                    </p:set>
+                                    <p:animEffect transition="in" filter="fade">
+                                      <p:cBhvr>
+                                        <p:cTn id="19" dur="500"/>
+                                        <p:tgtEl>
+                                          <p:spTgt spid="19"/>
+                                        </p:tgtEl>
+                                      </p:cBhvr>
+                                    </p:animEffect>
+                                  </p:childTnLst>
+                                </p:cTn>
+                              </p:par>
+                              <p:par>
+                                <p:cTn id="20" presetID="10" presetClass="entr" presetSubtype="0" fill="hold" nodeType="withEffect">
+                                  <p:stCondLst>
+                                    <p:cond delay="1500"/>
+                                  </p:stCondLst>
+                                  <p:childTnLst>
+                                    <p:set>
+                                      <p:cBhvr>
+                                        <p:cTn id="21" dur="1" fill="hold">
+                                          <p:stCondLst>
+                                            <p:cond delay="0"/>
+                                          </p:stCondLst>
+                                        </p:cTn>
+                                        <p:tgtEl>
+                                          <p:spTgt spid="23"/>
+                                        </p:tgtEl>
+                                        <p:attrNameLst>
+                                          <p:attrName>style.visibility</p:attrName>
+                                        </p:attrNameLst>
+                                      </p:cBhvr>
+                                      <p:to>
+                                        <p:strVal val="visible"/>
+                                      </p:to>
+                                    </p:set>
+                                    <p:animEffect transition="in" filter="fade">
+                                      <p:cBhvr>
+                                        <p:cTn id="22" dur="500"/>
+                                        <p:tgtEl>
+                                          <p:spTgt spid="23"/>
+                                        </p:tgtEl>
+                                      </p:cBhvr>
+                                    </p:animEffect>
+                                  </p:childTnLst>
+                                </p:cTn>
+                              </p:par>
+                            </p:childTnLst>
+                          </p:cTn>
+                        </p:par>
+                      </p:childTnLst>
+                    </p:cTn>
+                  </p:par>
+                </p:childTnLst>
+              </p:cTn>
+              <p:prevCondLst>
+                <p:cond evt="onPrev" delay="0">
+                  <p:tgtEl>
+                    <p:sldTgt/>
+                  </p:tgtEl>
+                </p:cond>
+              </p:prevCondLst>
+              <p:nextCondLst>
+                <p:cond evt="onNext" delay="0">
+                  <p:tgtEl>
+                    <p:sldTgt/>
+                  </p:tgtEl>
+                </p:cond>
+              </p:nextCondLst>
+            </p:seq>
+          </p:childTnLst>
+        </p:cTn>
+      </p:par>
+    </p:tnLst>
+  </p:timing>
 </p:sld>
 </file>
 
@@ -17855,6 +20403,139 @@
   <p:clrMapOvr>
     <a:masterClrMapping/>
   </p:clrMapOvr>
+  <mc:AlternateContent xmlns:mc="http://schemas.openxmlformats.org/markup-compatibility/2006">
+    <mc:Choice xmlns:p14="http://schemas.microsoft.com/office/powerpoint/2010/main" Requires="p14">
+      <p:transition spd="med" p14:dur="700">
+        <p:fade/>
+      </p:transition>
+    </mc:Choice>
+    <mc:Fallback>
+      <p:transition spd="med">
+        <p:fade/>
+      </p:transition>
+    </mc:Fallback>
+  </mc:AlternateContent>
+  <p:timing>
+    <p:tnLst>
+      <p:par>
+        <p:cTn id="1" dur="indefinite" restart="never" nodeType="tmRoot">
+          <p:childTnLst>
+            <p:seq concurrent="1" nextAc="seek">
+              <p:cTn id="2" dur="indefinite" nodeType="mainSeq">
+                <p:childTnLst>
+                  <p:par>
+                    <p:cTn id="3" fill="hold">
+                      <p:stCondLst>
+                        <p:cond delay="indefinite"/>
+                        <p:cond evt="onBegin" delay="0">
+                          <p:tn val="2"/>
+                        </p:cond>
+                      </p:stCondLst>
+                      <p:childTnLst>
+                        <p:par>
+                          <p:cTn id="4" fill="hold">
+                            <p:stCondLst>
+                              <p:cond delay="0"/>
+                            </p:stCondLst>
+                            <p:childTnLst>
+                              <p:par>
+                                <p:cTn id="5" presetID="10" presetClass="entr" presetSubtype="0" fill="hold" nodeType="afterEffect">
+                                  <p:stCondLst>
+                                    <p:cond delay="0"/>
+                                  </p:stCondLst>
+                                  <p:childTnLst>
+                                    <p:set>
+                                      <p:cBhvr>
+                                        <p:cTn id="6" dur="1" fill="hold">
+                                          <p:stCondLst>
+                                            <p:cond delay="0"/>
+                                          </p:stCondLst>
+                                        </p:cTn>
+                                        <p:tgtEl>
+                                          <p:spTgt spid="4"/>
+                                        </p:tgtEl>
+                                        <p:attrNameLst>
+                                          <p:attrName>style.visibility</p:attrName>
+                                        </p:attrNameLst>
+                                      </p:cBhvr>
+                                      <p:to>
+                                        <p:strVal val="visible"/>
+                                      </p:to>
+                                    </p:set>
+                                    <p:animEffect transition="in" filter="fade">
+                                      <p:cBhvr>
+                                        <p:cTn id="7" dur="500"/>
+                                        <p:tgtEl>
+                                          <p:spTgt spid="4"/>
+                                        </p:tgtEl>
+                                      </p:cBhvr>
+                                    </p:animEffect>
+                                  </p:childTnLst>
+                                </p:cTn>
+                              </p:par>
+                              <p:par>
+                                <p:cTn id="8" presetID="10" presetClass="entr" presetSubtype="0" fill="hold" nodeType="withEffect">
+                                  <p:stCondLst>
+                                    <p:cond delay="300"/>
+                                  </p:stCondLst>
+                                  <p:childTnLst>
+                                    <p:set>
+                                      <p:cBhvr>
+                                        <p:cTn id="9" dur="1" fill="hold">
+                                          <p:stCondLst>
+                                            <p:cond delay="0"/>
+                                          </p:stCondLst>
+                                        </p:cTn>
+                                        <p:tgtEl>
+                                          <p:spTgt spid="13"/>
+                                        </p:tgtEl>
+                                        <p:attrNameLst>
+                                          <p:attrName>style.visibility</p:attrName>
+                                        </p:attrNameLst>
+                                      </p:cBhvr>
+                                      <p:to>
+                                        <p:strVal val="visible"/>
+                                      </p:to>
+                                    </p:set>
+                                    <p:animEffect transition="in" filter="fade">
+                                      <p:cBhvr>
+                                        <p:cTn id="10" dur="500"/>
+                                        <p:tgtEl>
+                                          <p:spTgt spid="13"/>
+                                        </p:tgtEl>
+                                      </p:cBhvr>
+                                    </p:animEffect>
+                                  </p:childTnLst>
+                                </p:cTn>
+                              </p:par>
+                            </p:childTnLst>
+                          </p:cTn>
+                        </p:par>
+                      </p:childTnLst>
+                    </p:cTn>
+                  </p:par>
+                </p:childTnLst>
+              </p:cTn>
+              <p:prevCondLst>
+                <p:cond evt="onPrev" delay="0">
+                  <p:tgtEl>
+                    <p:sldTgt/>
+                  </p:tgtEl>
+                </p:cond>
+              </p:prevCondLst>
+              <p:nextCondLst>
+                <p:cond evt="onNext" delay="0">
+                  <p:tgtEl>
+                    <p:sldTgt/>
+                  </p:tgtEl>
+                </p:cond>
+              </p:nextCondLst>
+            </p:seq>
+          </p:childTnLst>
+        </p:cTn>
+      </p:par>
+    </p:tnLst>
+  </p:timing>
 </p:sld>
 </file>
 
@@ -20405,6 +23086,174 @@
   <p:clrMapOvr>
     <a:masterClrMapping/>
   </p:clrMapOvr>
+  <mc:AlternateContent xmlns:mc="http://schemas.openxmlformats.org/markup-compatibility/2006">
+    <mc:Choice xmlns:p14="http://schemas.microsoft.com/office/powerpoint/2010/main" Requires="p14">
+      <p:transition spd="med" p14:dur="700">
+        <p:fade/>
+      </p:transition>
+    </mc:Choice>
+    <mc:Fallback>
+      <p:transition spd="med">
+        <p:fade/>
+      </p:transition>
+    </mc:Fallback>
+  </mc:AlternateContent>
+  <p:timing>
+    <p:tnLst>
+      <p:par>
+        <p:cTn id="1" dur="indefinite" restart="never" nodeType="tmRoot">
+          <p:childTnLst>
+            <p:seq concurrent="1" nextAc="seek">
+              <p:cTn id="2" dur="indefinite" nodeType="mainSeq">
+                <p:childTnLst>
+                  <p:par>
+                    <p:cTn id="3" fill="hold">
+                      <p:stCondLst>
+                        <p:cond delay="indefinite"/>
+                        <p:cond evt="onBegin" delay="0">
+                          <p:tn val="2"/>
+                        </p:cond>
+                      </p:stCondLst>
+                      <p:childTnLst>
+                        <p:par>
+                          <p:cTn id="4" fill="hold">
+                            <p:stCondLst>
+                              <p:cond delay="0"/>
+                            </p:stCondLst>
+                            <p:childTnLst>
+                              <p:par>
+                                <p:cTn id="5" presetID="10" presetClass="entr" presetSubtype="0" fill="hold" nodeType="afterEffect">
+                                  <p:stCondLst>
+                                    <p:cond delay="0"/>
+                                  </p:stCondLst>
+                                  <p:childTnLst>
+                                    <p:set>
+                                      <p:cBhvr>
+                                        <p:cTn id="6" dur="1" fill="hold">
+                                          <p:stCondLst>
+                                            <p:cond delay="0"/>
+                                          </p:stCondLst>
+                                        </p:cTn>
+                                        <p:tgtEl>
+                                          <p:spTgt spid="4"/>
+                                        </p:tgtEl>
+                                        <p:attrNameLst>
+                                          <p:attrName>style.visibility</p:attrName>
+                                        </p:attrNameLst>
+                                      </p:cBhvr>
+                                      <p:to>
+                                        <p:strVal val="visible"/>
+                                      </p:to>
+                                    </p:set>
+                                    <p:animEffect transition="in" filter="fade">
+                                      <p:cBhvr>
+                                        <p:cTn id="7" dur="500"/>
+                                        <p:tgtEl>
+                                          <p:spTgt spid="4"/>
+                                        </p:tgtEl>
+                                      </p:cBhvr>
+                                    </p:animEffect>
+                                  </p:childTnLst>
+                                </p:cTn>
+                              </p:par>
+                              <p:par>
+                                <p:cTn id="8" presetID="10" presetClass="entr" presetSubtype="0" fill="hold" nodeType="withEffect">
+                                  <p:stCondLst>
+                                    <p:cond delay="300"/>
+                                  </p:stCondLst>
+                                  <p:childTnLst>
+                                    <p:set>
+                                      <p:cBhvr>
+                                        <p:cTn id="9" dur="1" fill="hold">
+                                          <p:stCondLst>
+                                            <p:cond delay="0"/>
+                                          </p:stCondLst>
+                                        </p:cTn>
+                                        <p:tgtEl>
+                                          <p:spTgt spid="29"/>
+                                        </p:tgtEl>
+                                        <p:attrNameLst>
+                                          <p:attrName>style.visibility</p:attrName>
+                                        </p:attrNameLst>
+                                      </p:cBhvr>
+                                      <p:to>
+                                        <p:strVal val="visible"/>
+                                      </p:to>
+                                    </p:set>
+                                    <p:animEffect transition="in" filter="fade">
+                                      <p:cBhvr>
+                                        <p:cTn id="10" dur="500"/>
+                                        <p:tgtEl>
+                                          <p:spTgt spid="29"/>
+                                        </p:tgtEl>
+                                      </p:cBhvr>
+                                    </p:animEffect>
+                                  </p:childTnLst>
+                                </p:cTn>
+                              </p:par>
+                              <p:par>
+                                <p:cTn id="11" presetID="10" presetClass="entr" presetSubtype="0" fill="hold" nodeType="withEffect">
+                                  <p:stCondLst>
+                                    <p:cond delay="600"/>
+                                  </p:stCondLst>
+                                  <p:childTnLst>
+                                    <p:set>
+                                      <p:cBhvr>
+                                        <p:cTn id="12" dur="1" fill="hold">
+                                          <p:stCondLst>
+                                            <p:cond delay="0"/>
+                                          </p:stCondLst>
+                                        </p:cTn>
+                                        <p:tgtEl>
+                                          <p:spTgt spid="81"/>
+                                        </p:tgtEl>
+                                        <p:attrNameLst>
+                                          <p:attrName>style.visibility</p:attrName>
+                                        </p:attrNameLst>
+                                      </p:cBhvr>
+                                      <p:to>
+                                        <p:strVal val="visible"/>
+                                      </p:to>
+                                    </p:set>
+                                    <p:animEffect transition="in" filter="fade">
+                                      <p:cBhvr>
+                                        <p:cTn id="13" dur="500"/>
+                                        <p:tgtEl>
+                                          <p:spTgt spid="81"/>
+                                        </p:tgtEl>
+                                      </p:cBhvr>
+                                    </p:animEffect>
+                                  </p:childTnLst>
+                                </p:cTn>
+                              </p:par>
+                            </p:childTnLst>
+                          </p:cTn>
+                        </p:par>
+                      </p:childTnLst>
+                    </p:cTn>
+                  </p:par>
+                </p:childTnLst>
+              </p:cTn>
+              <p:prevCondLst>
+                <p:cond evt="onPrev" delay="0">
+                  <p:tgtEl>
+                    <p:sldTgt/>
+                  </p:tgtEl>
+                </p:cond>
+              </p:prevCondLst>
+              <p:nextCondLst>
+                <p:cond evt="onNext" delay="0">
+                  <p:tgtEl>
+                    <p:sldTgt/>
+                  </p:tgtEl>
+                </p:cond>
+              </p:nextCondLst>
+            </p:seq>
+          </p:childTnLst>
+        </p:cTn>
+      </p:par>
+    </p:tnLst>
+  </p:timing>
 </p:sld>
 </file>
 
@@ -23682,6 +26531,174 @@
   <p:clrMapOvr>
     <a:masterClrMapping/>
   </p:clrMapOvr>
+  <mc:AlternateContent xmlns:mc="http://schemas.openxmlformats.org/markup-compatibility/2006">
+    <mc:Choice xmlns:p14="http://schemas.microsoft.com/office/powerpoint/2010/main" Requires="p14">
+      <p:transition spd="med" p14:dur="700">
+        <p:fade/>
+      </p:transition>
+    </mc:Choice>
+    <mc:Fallback>
+      <p:transition spd="med">
+        <p:fade/>
+      </p:transition>
+    </mc:Fallback>
+  </mc:AlternateContent>
+  <p:timing>
+    <p:tnLst>
+      <p:par>
+        <p:cTn id="1" dur="indefinite" restart="never" nodeType="tmRoot">
+          <p:childTnLst>
+            <p:seq concurrent="1" nextAc="seek">
+              <p:cTn id="2" dur="indefinite" nodeType="mainSeq">
+                <p:childTnLst>
+                  <p:par>
+                    <p:cTn id="3" fill="hold">
+                      <p:stCondLst>
+                        <p:cond delay="indefinite"/>
+                        <p:cond evt="onBegin" delay="0">
+                          <p:tn val="2"/>
+                        </p:cond>
+                      </p:stCondLst>
+                      <p:childTnLst>
+                        <p:par>
+                          <p:cTn id="4" fill="hold">
+                            <p:stCondLst>
+                              <p:cond delay="0"/>
+                            </p:stCondLst>
+                            <p:childTnLst>
+                              <p:par>
+                                <p:cTn id="5" presetID="10" presetClass="entr" presetSubtype="0" fill="hold" nodeType="afterEffect">
+                                  <p:stCondLst>
+                                    <p:cond delay="0"/>
+                                  </p:stCondLst>
+                                  <p:childTnLst>
+                                    <p:set>
+                                      <p:cBhvr>
+                                        <p:cTn id="6" dur="1" fill="hold">
+                                          <p:stCondLst>
+                                            <p:cond delay="0"/>
+                                          </p:stCondLst>
+                                        </p:cTn>
+                                        <p:tgtEl>
+                                          <p:spTgt spid="4"/>
+                                        </p:tgtEl>
+                                        <p:attrNameLst>
+                                          <p:attrName>style.visibility</p:attrName>
+                                        </p:attrNameLst>
+                                      </p:cBhvr>
+                                      <p:to>
+                                        <p:strVal val="visible"/>
+                                      </p:to>
+                                    </p:set>
+                                    <p:animEffect transition="in" filter="fade">
+                                      <p:cBhvr>
+                                        <p:cTn id="7" dur="500"/>
+                                        <p:tgtEl>
+                                          <p:spTgt spid="4"/>
+                                        </p:tgtEl>
+                                      </p:cBhvr>
+                                    </p:animEffect>
+                                  </p:childTnLst>
+                                </p:cTn>
+                              </p:par>
+                              <p:par>
+                                <p:cTn id="8" presetID="10" presetClass="entr" presetSubtype="0" fill="hold" nodeType="withEffect">
+                                  <p:stCondLst>
+                                    <p:cond delay="300"/>
+                                  </p:stCondLst>
+                                  <p:childTnLst>
+                                    <p:set>
+                                      <p:cBhvr>
+                                        <p:cTn id="9" dur="1" fill="hold">
+                                          <p:stCondLst>
+                                            <p:cond delay="0"/>
+                                          </p:stCondLst>
+                                        </p:cTn>
+                                        <p:tgtEl>
+                                          <p:spTgt spid="24"/>
+                                        </p:tgtEl>
+                                        <p:attrNameLst>
+                                          <p:attrName>style.visibility</p:attrName>
+                                        </p:attrNameLst>
+                                      </p:cBhvr>
+                                      <p:to>
+                                        <p:strVal val="visible"/>
+                                      </p:to>
+                                    </p:set>
+                                    <p:animEffect transition="in" filter="fade">
+                                      <p:cBhvr>
+                                        <p:cTn id="10" dur="500"/>
+                                        <p:tgtEl>
+                                          <p:spTgt spid="24"/>
+                                        </p:tgtEl>
+                                      </p:cBhvr>
+                                    </p:animEffect>
+                                  </p:childTnLst>
+                                </p:cTn>
+                              </p:par>
+                              <p:par>
+                                <p:cTn id="11" presetID="10" presetClass="entr" presetSubtype="0" fill="hold" nodeType="withEffect">
+                                  <p:stCondLst>
+                                    <p:cond delay="600"/>
+                                  </p:stCondLst>
+                                  <p:childTnLst>
+                                    <p:set>
+                                      <p:cBhvr>
+                                        <p:cTn id="12" dur="1" fill="hold">
+                                          <p:stCondLst>
+                                            <p:cond delay="0"/>
+                                          </p:stCondLst>
+                                        </p:cTn>
+                                        <p:tgtEl>
+                                          <p:spTgt spid="101"/>
+                                        </p:tgtEl>
+                                        <p:attrNameLst>
+                                          <p:attrName>style.visibility</p:attrName>
+                                        </p:attrNameLst>
+                                      </p:cBhvr>
+                                      <p:to>
+                                        <p:strVal val="visible"/>
+                                      </p:to>
+                                    </p:set>
+                                    <p:animEffect transition="in" filter="fade">
+                                      <p:cBhvr>
+                                        <p:cTn id="13" dur="500"/>
+                                        <p:tgtEl>
+                                          <p:spTgt spid="101"/>
+                                        </p:tgtEl>
+                                      </p:cBhvr>
+                                    </p:animEffect>
+                                  </p:childTnLst>
+                                </p:cTn>
+                              </p:par>
+                            </p:childTnLst>
+                          </p:cTn>
+                        </p:par>
+                      </p:childTnLst>
+                    </p:cTn>
+                  </p:par>
+                </p:childTnLst>
+              </p:cTn>
+              <p:prevCondLst>
+                <p:cond evt="onPrev" delay="0">
+                  <p:tgtEl>
+                    <p:sldTgt/>
+                  </p:tgtEl>
+                </p:cond>
+              </p:prevCondLst>
+              <p:nextCondLst>
+                <p:cond evt="onNext" delay="0">
+                  <p:tgtEl>
+                    <p:sldTgt/>
+                  </p:tgtEl>
+                </p:cond>
+              </p:nextCondLst>
+            </p:seq>
+          </p:childTnLst>
+        </p:cTn>
+      </p:par>
+    </p:tnLst>
+  </p:timing>
 </p:sld>
 </file>
 
@@ -26098,6 +29115,139 @@
   <p:clrMapOvr>
     <a:masterClrMapping/>
   </p:clrMapOvr>
+  <mc:AlternateContent xmlns:mc="http://schemas.openxmlformats.org/markup-compatibility/2006">
+    <mc:Choice xmlns:p14="http://schemas.microsoft.com/office/powerpoint/2010/main" Requires="p14">
+      <p:transition spd="med" p14:dur="700">
+        <p:fade/>
+      </p:transition>
+    </mc:Choice>
+    <mc:Fallback>
+      <p:transition spd="med">
+        <p:fade/>
+      </p:transition>
+    </mc:Fallback>
+  </mc:AlternateContent>
+  <p:timing>
+    <p:tnLst>
+      <p:par>
+        <p:cTn id="1" dur="indefinite" restart="never" nodeType="tmRoot">
+          <p:childTnLst>
+            <p:seq concurrent="1" nextAc="seek">
+              <p:cTn id="2" dur="indefinite" nodeType="mainSeq">
+                <p:childTnLst>
+                  <p:par>
+                    <p:cTn id="3" fill="hold">
+                      <p:stCondLst>
+                        <p:cond delay="indefinite"/>
+                        <p:cond evt="onBegin" delay="0">
+                          <p:tn val="2"/>
+                        </p:cond>
+                      </p:stCondLst>
+                      <p:childTnLst>
+                        <p:par>
+                          <p:cTn id="4" fill="hold">
+                            <p:stCondLst>
+                              <p:cond delay="0"/>
+                            </p:stCondLst>
+                            <p:childTnLst>
+                              <p:par>
+                                <p:cTn id="5" presetID="10" presetClass="entr" presetSubtype="0" fill="hold" nodeType="afterEffect">
+                                  <p:stCondLst>
+                                    <p:cond delay="0"/>
+                                  </p:stCondLst>
+                                  <p:childTnLst>
+                                    <p:set>
+                                      <p:cBhvr>
+                                        <p:cTn id="6" dur="1" fill="hold">
+                                          <p:stCondLst>
+                                            <p:cond delay="0"/>
+                                          </p:stCondLst>
+                                        </p:cTn>
+                                        <p:tgtEl>
+                                          <p:spTgt spid="4"/>
+                                        </p:tgtEl>
+                                        <p:attrNameLst>
+                                          <p:attrName>style.visibility</p:attrName>
+                                        </p:attrNameLst>
+                                      </p:cBhvr>
+                                      <p:to>
+                                        <p:strVal val="visible"/>
+                                      </p:to>
+                                    </p:set>
+                                    <p:animEffect transition="in" filter="fade">
+                                      <p:cBhvr>
+                                        <p:cTn id="7" dur="500"/>
+                                        <p:tgtEl>
+                                          <p:spTgt spid="4"/>
+                                        </p:tgtEl>
+                                      </p:cBhvr>
+                                    </p:animEffect>
+                                  </p:childTnLst>
+                                </p:cTn>
+                              </p:par>
+                              <p:par>
+                                <p:cTn id="8" presetID="10" presetClass="entr" presetSubtype="0" fill="hold" nodeType="withEffect">
+                                  <p:stCondLst>
+                                    <p:cond delay="300"/>
+                                  </p:stCondLst>
+                                  <p:childTnLst>
+                                    <p:set>
+                                      <p:cBhvr>
+                                        <p:cTn id="9" dur="1" fill="hold">
+                                          <p:stCondLst>
+                                            <p:cond delay="0"/>
+                                          </p:stCondLst>
+                                        </p:cTn>
+                                        <p:tgtEl>
+                                          <p:spTgt spid="69"/>
+                                        </p:tgtEl>
+                                        <p:attrNameLst>
+                                          <p:attrName>style.visibility</p:attrName>
+                                        </p:attrNameLst>
+                                      </p:cBhvr>
+                                      <p:to>
+                                        <p:strVal val="visible"/>
+                                      </p:to>
+                                    </p:set>
+                                    <p:animEffect transition="in" filter="fade">
+                                      <p:cBhvr>
+                                        <p:cTn id="10" dur="500"/>
+                                        <p:tgtEl>
+                                          <p:spTgt spid="69"/>
+                                        </p:tgtEl>
+                                      </p:cBhvr>
+                                    </p:animEffect>
+                                  </p:childTnLst>
+                                </p:cTn>
+                              </p:par>
+                            </p:childTnLst>
+                          </p:cTn>
+                        </p:par>
+                      </p:childTnLst>
+                    </p:cTn>
+                  </p:par>
+                </p:childTnLst>
+              </p:cTn>
+              <p:prevCondLst>
+                <p:cond evt="onPrev" delay="0">
+                  <p:tgtEl>
+                    <p:sldTgt/>
+                  </p:tgtEl>
+                </p:cond>
+              </p:prevCondLst>
+              <p:nextCondLst>
+                <p:cond evt="onNext" delay="0">
+                  <p:tgtEl>
+                    <p:sldTgt/>
+                  </p:tgtEl>
+                </p:cond>
+              </p:nextCondLst>
+            </p:seq>
+          </p:childTnLst>
+        </p:cTn>
+      </p:par>
+    </p:tnLst>
+  </p:timing>
 </p:sld>
 </file>
 
@@ -27971,6 +31121,244 @@
   <p:clrMapOvr>
     <a:masterClrMapping/>
   </p:clrMapOvr>
+  <mc:AlternateContent xmlns:mc="http://schemas.openxmlformats.org/markup-compatibility/2006">
+    <mc:Choice xmlns:p14="http://schemas.microsoft.com/office/powerpoint/2010/main" Requires="p14">
+      <p:transition spd="med" p14:dur="700">
+        <p:fade/>
+      </p:transition>
+    </mc:Choice>
+    <mc:Fallback>
+      <p:transition spd="med">
+        <p:fade/>
+      </p:transition>
+    </mc:Fallback>
+  </mc:AlternateContent>
+  <p:timing>
+    <p:tnLst>
+      <p:par>
+        <p:cTn id="1" dur="indefinite" restart="never" nodeType="tmRoot">
+          <p:childTnLst>
+            <p:seq concurrent="1" nextAc="seek">
+              <p:cTn id="2" dur="indefinite" nodeType="mainSeq">
+                <p:childTnLst>
+                  <p:par>
+                    <p:cTn id="3" fill="hold">
+                      <p:stCondLst>
+                        <p:cond delay="indefinite"/>
+                        <p:cond evt="onBegin" delay="0">
+                          <p:tn val="2"/>
+                        </p:cond>
+                      </p:stCondLst>
+                      <p:childTnLst>
+                        <p:par>
+                          <p:cTn id="4" fill="hold">
+                            <p:stCondLst>
+                              <p:cond delay="0"/>
+                            </p:stCondLst>
+                            <p:childTnLst>
+                              <p:par>
+                                <p:cTn id="5" presetID="10" presetClass="entr" presetSubtype="0" fill="hold" nodeType="afterEffect">
+                                  <p:stCondLst>
+                                    <p:cond delay="0"/>
+                                  </p:stCondLst>
+                                  <p:childTnLst>
+                                    <p:set>
+                                      <p:cBhvr>
+                                        <p:cTn id="6" dur="1" fill="hold">
+                                          <p:stCondLst>
+                                            <p:cond delay="0"/>
+                                          </p:stCondLst>
+                                        </p:cTn>
+                                        <p:tgtEl>
+                                          <p:spTgt spid="4"/>
+                                        </p:tgtEl>
+                                        <p:attrNameLst>
+                                          <p:attrName>style.visibility</p:attrName>
+                                        </p:attrNameLst>
+                                      </p:cBhvr>
+                                      <p:to>
+                                        <p:strVal val="visible"/>
+                                      </p:to>
+                                    </p:set>
+                                    <p:animEffect transition="in" filter="fade">
+                                      <p:cBhvr>
+                                        <p:cTn id="7" dur="500"/>
+                                        <p:tgtEl>
+                                          <p:spTgt spid="4"/>
+                                        </p:tgtEl>
+                                      </p:cBhvr>
+                                    </p:animEffect>
+                                  </p:childTnLst>
+                                </p:cTn>
+                              </p:par>
+                              <p:par>
+                                <p:cTn id="8" presetID="10" presetClass="entr" presetSubtype="0" fill="hold" nodeType="withEffect">
+                                  <p:stCondLst>
+                                    <p:cond delay="300"/>
+                                  </p:stCondLst>
+                                  <p:childTnLst>
+                                    <p:set>
+                                      <p:cBhvr>
+                                        <p:cTn id="9" dur="1" fill="hold">
+                                          <p:stCondLst>
+                                            <p:cond delay="0"/>
+                                          </p:stCondLst>
+                                        </p:cTn>
+                                        <p:tgtEl>
+                                          <p:spTgt spid="17"/>
+                                        </p:tgtEl>
+                                        <p:attrNameLst>
+                                          <p:attrName>style.visibility</p:attrName>
+                                        </p:attrNameLst>
+                                      </p:cBhvr>
+                                      <p:to>
+                                        <p:strVal val="visible"/>
+                                      </p:to>
+                                    </p:set>
+                                    <p:animEffect transition="in" filter="fade">
+                                      <p:cBhvr>
+                                        <p:cTn id="10" dur="500"/>
+                                        <p:tgtEl>
+                                          <p:spTgt spid="17"/>
+                                        </p:tgtEl>
+                                      </p:cBhvr>
+                                    </p:animEffect>
+                                  </p:childTnLst>
+                                </p:cTn>
+                              </p:par>
+                              <p:par>
+                                <p:cTn id="11" presetID="10" presetClass="entr" presetSubtype="0" fill="hold" nodeType="withEffect">
+                                  <p:stCondLst>
+                                    <p:cond delay="600"/>
+                                  </p:stCondLst>
+                                  <p:childTnLst>
+                                    <p:set>
+                                      <p:cBhvr>
+                                        <p:cTn id="12" dur="1" fill="hold">
+                                          <p:stCondLst>
+                                            <p:cond delay="0"/>
+                                          </p:stCondLst>
+                                        </p:cTn>
+                                        <p:tgtEl>
+                                          <p:spTgt spid="28"/>
+                                        </p:tgtEl>
+                                        <p:attrNameLst>
+                                          <p:attrName>style.visibility</p:attrName>
+                                        </p:attrNameLst>
+                                      </p:cBhvr>
+                                      <p:to>
+                                        <p:strVal val="visible"/>
+                                      </p:to>
+                                    </p:set>
+                                    <p:animEffect transition="in" filter="fade">
+                                      <p:cBhvr>
+                                        <p:cTn id="13" dur="500"/>
+                                        <p:tgtEl>
+                                          <p:spTgt spid="28"/>
+                                        </p:tgtEl>
+                                      </p:cBhvr>
+                                    </p:animEffect>
+                                  </p:childTnLst>
+                                </p:cTn>
+                              </p:par>
+                              <p:par>
+                                <p:cTn id="14" presetID="10" presetClass="entr" presetSubtype="0" fill="hold" nodeType="withEffect">
+                                  <p:stCondLst>
+                                    <p:cond delay="900"/>
+                                  </p:stCondLst>
+                                  <p:childTnLst>
+                                    <p:set>
+                                      <p:cBhvr>
+                                        <p:cTn id="15" dur="1" fill="hold">
+                                          <p:stCondLst>
+                                            <p:cond delay="0"/>
+                                          </p:stCondLst>
+                                        </p:cTn>
+                                        <p:tgtEl>
+                                          <p:spTgt spid="48"/>
+                                        </p:tgtEl>
+                                        <p:attrNameLst>
+                                          <p:attrName>style.visibility</p:attrName>
+                                        </p:attrNameLst>
+                                      </p:cBhvr>
+                                      <p:to>
+                                        <p:strVal val="visible"/>
+                                      </p:to>
+                                    </p:set>
+                                    <p:animEffect transition="in" filter="fade">
+                                      <p:cBhvr>
+                                        <p:cTn id="16" dur="500"/>
+                                        <p:tgtEl>
+                                          <p:spTgt spid="48"/>
+                                        </p:tgtEl>
+                                      </p:cBhvr>
+                                    </p:animEffect>
+                                  </p:childTnLst>
+                                </p:cTn>
+                              </p:par>
+                              <p:par>
+                                <p:cTn id="17" presetID="10" presetClass="entr" presetSubtype="0" fill="hold" nodeType="withEffect">
+                                  <p:stCondLst>
+                                    <p:cond delay="1200"/>
+                                  </p:stCondLst>
+                                  <p:childTnLst>
+                                    <p:set>
+                                      <p:cBhvr>
+                                        <p:cTn id="18" dur="1" fill="hold">
+                                          <p:stCondLst>
+                                            <p:cond delay="0"/>
+                                          </p:stCondLst>
+                                        </p:cTn>
+                                        <p:tgtEl>
+                                          <p:spTgt spid="57"/>
+                                        </p:tgtEl>
+                                        <p:attrNameLst>
+                                          <p:attrName>style.visibility</p:attrName>
+                                        </p:attrNameLst>
+                                      </p:cBhvr>
+                                      <p:to>
+                                        <p:strVal val="visible"/>
+                                      </p:to>
+                                    </p:set>
+                                    <p:animEffect transition="in" filter="fade">
+                                      <p:cBhvr>
+                                        <p:cTn id="19" dur="500"/>
+                                        <p:tgtEl>
+                                          <p:spTgt spid="57"/>
+                                        </p:tgtEl>
+                                      </p:cBhvr>
+                                    </p:animEffect>
+                                  </p:childTnLst>
+                                </p:cTn>
+                              </p:par>
+                            </p:childTnLst>
+                          </p:cTn>
+                        </p:par>
+                      </p:childTnLst>
+                    </p:cTn>
+                  </p:par>
+                </p:childTnLst>
+              </p:cTn>
+              <p:prevCondLst>
+                <p:cond evt="onPrev" delay="0">
+                  <p:tgtEl>
+                    <p:sldTgt/>
+                  </p:tgtEl>
+                </p:cond>
+              </p:prevCondLst>
+              <p:nextCondLst>
+                <p:cond evt="onNext" delay="0">
+                  <p:tgtEl>
+                    <p:sldTgt/>
+                  </p:tgtEl>
+                </p:cond>
+              </p:nextCondLst>
+            </p:seq>
+          </p:childTnLst>
+        </p:cTn>
+      </p:par>
+    </p:tnLst>
+  </p:timing>
 </p:sld>
 </file>
 
@@ -33901,6 +37289,209 @@
   <p:clrMapOvr>
     <a:masterClrMapping/>
   </p:clrMapOvr>
+  <mc:AlternateContent xmlns:mc="http://schemas.openxmlformats.org/markup-compatibility/2006">
+    <mc:Choice xmlns:p14="http://schemas.microsoft.com/office/powerpoint/2010/main" Requires="p14">
+      <p:transition spd="med" p14:dur="700">
+        <p:fade/>
+      </p:transition>
+    </mc:Choice>
+    <mc:Fallback>
+      <p:transition spd="med">
+        <p:fade/>
+      </p:transition>
+    </mc:Fallback>
+  </mc:AlternateContent>
+  <p:timing>
+    <p:tnLst>
+      <p:par>
+        <p:cTn id="1" dur="indefinite" restart="never" nodeType="tmRoot">
+          <p:childTnLst>
+            <p:seq concurrent="1" nextAc="seek">
+              <p:cTn id="2" dur="indefinite" nodeType="mainSeq">
+                <p:childTnLst>
+                  <p:par>
+                    <p:cTn id="3" fill="hold">
+                      <p:stCondLst>
+                        <p:cond delay="indefinite"/>
+                        <p:cond evt="onBegin" delay="0">
+                          <p:tn val="2"/>
+                        </p:cond>
+                      </p:stCondLst>
+                      <p:childTnLst>
+                        <p:par>
+                          <p:cTn id="4" fill="hold">
+                            <p:stCondLst>
+                              <p:cond delay="0"/>
+                            </p:stCondLst>
+                            <p:childTnLst>
+                              <p:par>
+                                <p:cTn id="5" presetID="10" presetClass="entr" presetSubtype="0" fill="hold" nodeType="afterEffect">
+                                  <p:stCondLst>
+                                    <p:cond delay="0"/>
+                                  </p:stCondLst>
+                                  <p:childTnLst>
+                                    <p:set>
+                                      <p:cBhvr>
+                                        <p:cTn id="6" dur="1" fill="hold">
+                                          <p:stCondLst>
+                                            <p:cond delay="0"/>
+                                          </p:stCondLst>
+                                        </p:cTn>
+                                        <p:tgtEl>
+                                          <p:spTgt spid="4"/>
+                                        </p:tgtEl>
+                                        <p:attrNameLst>
+                                          <p:attrName>style.visibility</p:attrName>
+                                        </p:attrNameLst>
+                                      </p:cBhvr>
+                                      <p:to>
+                                        <p:strVal val="visible"/>
+                                      </p:to>
+                                    </p:set>
+                                    <p:animEffect transition="in" filter="fade">
+                                      <p:cBhvr>
+                                        <p:cTn id="7" dur="500"/>
+                                        <p:tgtEl>
+                                          <p:spTgt spid="4"/>
+                                        </p:tgtEl>
+                                      </p:cBhvr>
+                                    </p:animEffect>
+                                  </p:childTnLst>
+                                </p:cTn>
+                              </p:par>
+                              <p:par>
+                                <p:cTn id="8" presetID="10" presetClass="entr" presetSubtype="0" fill="hold" nodeType="withEffect">
+                                  <p:stCondLst>
+                                    <p:cond delay="300"/>
+                                  </p:stCondLst>
+                                  <p:childTnLst>
+                                    <p:set>
+                                      <p:cBhvr>
+                                        <p:cTn id="9" dur="1" fill="hold">
+                                          <p:stCondLst>
+                                            <p:cond delay="0"/>
+                                          </p:stCondLst>
+                                        </p:cTn>
+                                        <p:tgtEl>
+                                          <p:spTgt spid="112"/>
+                                        </p:tgtEl>
+                                        <p:attrNameLst>
+                                          <p:attrName>style.visibility</p:attrName>
+                                        </p:attrNameLst>
+                                      </p:cBhvr>
+                                      <p:to>
+                                        <p:strVal val="visible"/>
+                                      </p:to>
+                                    </p:set>
+                                    <p:animEffect transition="in" filter="fade">
+                                      <p:cBhvr>
+                                        <p:cTn id="10" dur="500"/>
+                                        <p:tgtEl>
+                                          <p:spTgt spid="112"/>
+                                        </p:tgtEl>
+                                      </p:cBhvr>
+                                    </p:animEffect>
+                                  </p:childTnLst>
+                                </p:cTn>
+                              </p:par>
+                              <p:par>
+                                <p:cTn id="11" presetID="10" presetClass="entr" presetSubtype="0" fill="hold" nodeType="withEffect">
+                                  <p:stCondLst>
+                                    <p:cond delay="600"/>
+                                  </p:stCondLst>
+                                  <p:childTnLst>
+                                    <p:set>
+                                      <p:cBhvr>
+                                        <p:cTn id="12" dur="1" fill="hold">
+                                          <p:stCondLst>
+                                            <p:cond delay="0"/>
+                                          </p:stCondLst>
+                                        </p:cTn>
+                                        <p:tgtEl>
+                                          <p:spTgt spid="147"/>
+                                        </p:tgtEl>
+                                        <p:attrNameLst>
+                                          <p:attrName>style.visibility</p:attrName>
+                                        </p:attrNameLst>
+                                      </p:cBhvr>
+                                      <p:to>
+                                        <p:strVal val="visible"/>
+                                      </p:to>
+                                    </p:set>
+                                    <p:animEffect transition="in" filter="fade">
+                                      <p:cBhvr>
+                                        <p:cTn id="13" dur="500"/>
+                                        <p:tgtEl>
+                                          <p:spTgt spid="147"/>
+                                        </p:tgtEl>
+                                      </p:cBhvr>
+                                    </p:animEffect>
+                                  </p:childTnLst>
+                                </p:cTn>
+                              </p:par>
+                              <p:par>
+                                <p:cTn id="14" presetID="10" presetClass="entr" presetSubtype="0" fill="hold" nodeType="withEffect">
+                                  <p:stCondLst>
+                                    <p:cond delay="900"/>
+                                  </p:stCondLst>
+                                  <p:childTnLst>
+                                    <p:set>
+                                      <p:cBhvr>
+                                        <p:cTn id="15" dur="1" fill="hold">
+                                          <p:stCondLst>
+                                            <p:cond delay="0"/>
+                                          </p:stCondLst>
+                                        </p:cTn>
+                                        <p:tgtEl>
+                                          <p:spTgt spid="206"/>
+                                        </p:tgtEl>
+                                        <p:attrNameLst>
+                                          <p:attrName>style.visibility</p:attrName>
+                                        </p:attrNameLst>
+                                      </p:cBhvr>
+                                      <p:to>
+                                        <p:strVal val="visible"/>
+                                      </p:to>
+                                    </p:set>
+                                    <p:animEffect transition="in" filter="fade">
+                                      <p:cBhvr>
+                                        <p:cTn id="16" dur="500"/>
+                                        <p:tgtEl>
+                                          <p:spTgt spid="206"/>
+                                        </p:tgtEl>
+                                      </p:cBhvr>
+                                    </p:animEffect>
+                                  </p:childTnLst>
+                                </p:cTn>
+                              </p:par>
+                            </p:childTnLst>
+                          </p:cTn>
+                        </p:par>
+                      </p:childTnLst>
+                    </p:cTn>
+                  </p:par>
+                </p:childTnLst>
+              </p:cTn>
+              <p:prevCondLst>
+                <p:cond evt="onPrev" delay="0">
+                  <p:tgtEl>
+                    <p:sldTgt/>
+                  </p:tgtEl>
+                </p:cond>
+              </p:prevCondLst>
+              <p:nextCondLst>
+                <p:cond evt="onNext" delay="0">
+                  <p:tgtEl>
+                    <p:sldTgt/>
+                  </p:tgtEl>
+                </p:cond>
+              </p:nextCondLst>
+            </p:seq>
+          </p:childTnLst>
+        </p:cTn>
+      </p:par>
+    </p:tnLst>
+  </p:timing>
 </p:sld>
 </file>
 
@@ -36603,6 +40194,279 @@
   <p:clrMapOvr>
     <a:masterClrMapping/>
   </p:clrMapOvr>
+  <mc:AlternateContent xmlns:mc="http://schemas.openxmlformats.org/markup-compatibility/2006">
+    <mc:Choice xmlns:p14="http://schemas.microsoft.com/office/powerpoint/2010/main" Requires="p14">
+      <p:transition spd="med" p14:dur="700">
+        <p:fade/>
+      </p:transition>
+    </mc:Choice>
+    <mc:Fallback>
+      <p:transition spd="med">
+        <p:fade/>
+      </p:transition>
+    </mc:Fallback>
+  </mc:AlternateContent>
+  <p:timing>
+    <p:tnLst>
+      <p:par>
+        <p:cTn id="1" dur="indefinite" restart="never" nodeType="tmRoot">
+          <p:childTnLst>
+            <p:seq concurrent="1" nextAc="seek">
+              <p:cTn id="2" dur="indefinite" nodeType="mainSeq">
+                <p:childTnLst>
+                  <p:par>
+                    <p:cTn id="3" fill="hold">
+                      <p:stCondLst>
+                        <p:cond delay="indefinite"/>
+                        <p:cond evt="onBegin" delay="0">
+                          <p:tn val="2"/>
+                        </p:cond>
+                      </p:stCondLst>
+                      <p:childTnLst>
+                        <p:par>
+                          <p:cTn id="4" fill="hold">
+                            <p:stCondLst>
+                              <p:cond delay="0"/>
+                            </p:stCondLst>
+                            <p:childTnLst>
+                              <p:par>
+                                <p:cTn id="5" presetID="10" presetClass="entr" presetSubtype="0" fill="hold" nodeType="afterEffect">
+                                  <p:stCondLst>
+                                    <p:cond delay="0"/>
+                                  </p:stCondLst>
+                                  <p:childTnLst>
+                                    <p:set>
+                                      <p:cBhvr>
+                                        <p:cTn id="6" dur="1" fill="hold">
+                                          <p:stCondLst>
+                                            <p:cond delay="0"/>
+                                          </p:stCondLst>
+                                        </p:cTn>
+                                        <p:tgtEl>
+                                          <p:spTgt spid="4"/>
+                                        </p:tgtEl>
+                                        <p:attrNameLst>
+                                          <p:attrName>style.visibility</p:attrName>
+                                        </p:attrNameLst>
+                                      </p:cBhvr>
+                                      <p:to>
+                                        <p:strVal val="visible"/>
+                                      </p:to>
+                                    </p:set>
+                                    <p:animEffect transition="in" filter="fade">
+                                      <p:cBhvr>
+                                        <p:cTn id="7" dur="500"/>
+                                        <p:tgtEl>
+                                          <p:spTgt spid="4"/>
+                                        </p:tgtEl>
+                                      </p:cBhvr>
+                                    </p:animEffect>
+                                  </p:childTnLst>
+                                </p:cTn>
+                              </p:par>
+                              <p:par>
+                                <p:cTn id="8" presetID="10" presetClass="entr" presetSubtype="0" fill="hold" nodeType="withEffect">
+                                  <p:stCondLst>
+                                    <p:cond delay="300"/>
+                                  </p:stCondLst>
+                                  <p:childTnLst>
+                                    <p:set>
+                                      <p:cBhvr>
+                                        <p:cTn id="9" dur="1" fill="hold">
+                                          <p:stCondLst>
+                                            <p:cond delay="0"/>
+                                          </p:stCondLst>
+                                        </p:cTn>
+                                        <p:tgtEl>
+                                          <p:spTgt spid="25"/>
+                                        </p:tgtEl>
+                                        <p:attrNameLst>
+                                          <p:attrName>style.visibility</p:attrName>
+                                        </p:attrNameLst>
+                                      </p:cBhvr>
+                                      <p:to>
+                                        <p:strVal val="visible"/>
+                                      </p:to>
+                                    </p:set>
+                                    <p:animEffect transition="in" filter="fade">
+                                      <p:cBhvr>
+                                        <p:cTn id="10" dur="500"/>
+                                        <p:tgtEl>
+                                          <p:spTgt spid="25"/>
+                                        </p:tgtEl>
+                                      </p:cBhvr>
+                                    </p:animEffect>
+                                  </p:childTnLst>
+                                </p:cTn>
+                              </p:par>
+                              <p:par>
+                                <p:cTn id="11" presetID="10" presetClass="entr" presetSubtype="0" fill="hold" nodeType="withEffect">
+                                  <p:stCondLst>
+                                    <p:cond delay="600"/>
+                                  </p:stCondLst>
+                                  <p:childTnLst>
+                                    <p:set>
+                                      <p:cBhvr>
+                                        <p:cTn id="12" dur="1" fill="hold">
+                                          <p:stCondLst>
+                                            <p:cond delay="0"/>
+                                          </p:stCondLst>
+                                        </p:cTn>
+                                        <p:tgtEl>
+                                          <p:spTgt spid="53"/>
+                                        </p:tgtEl>
+                                        <p:attrNameLst>
+                                          <p:attrName>style.visibility</p:attrName>
+                                        </p:attrNameLst>
+                                      </p:cBhvr>
+                                      <p:to>
+                                        <p:strVal val="visible"/>
+                                      </p:to>
+                                    </p:set>
+                                    <p:animEffect transition="in" filter="fade">
+                                      <p:cBhvr>
+                                        <p:cTn id="13" dur="500"/>
+                                        <p:tgtEl>
+                                          <p:spTgt spid="53"/>
+                                        </p:tgtEl>
+                                      </p:cBhvr>
+                                    </p:animEffect>
+                                  </p:childTnLst>
+                                </p:cTn>
+                              </p:par>
+                              <p:par>
+                                <p:cTn id="14" presetID="10" presetClass="entr" presetSubtype="0" fill="hold" nodeType="withEffect">
+                                  <p:stCondLst>
+                                    <p:cond delay="900"/>
+                                  </p:stCondLst>
+                                  <p:childTnLst>
+                                    <p:set>
+                                      <p:cBhvr>
+                                        <p:cTn id="15" dur="1" fill="hold">
+                                          <p:stCondLst>
+                                            <p:cond delay="0"/>
+                                          </p:stCondLst>
+                                        </p:cTn>
+                                        <p:tgtEl>
+                                          <p:spTgt spid="81"/>
+                                        </p:tgtEl>
+                                        <p:attrNameLst>
+                                          <p:attrName>style.visibility</p:attrName>
+                                        </p:attrNameLst>
+                                      </p:cBhvr>
+                                      <p:to>
+                                        <p:strVal val="visible"/>
+                                      </p:to>
+                                    </p:set>
+                                    <p:animEffect transition="in" filter="fade">
+                                      <p:cBhvr>
+                                        <p:cTn id="16" dur="500"/>
+                                        <p:tgtEl>
+                                          <p:spTgt spid="81"/>
+                                        </p:tgtEl>
+                                      </p:cBhvr>
+                                    </p:animEffect>
+                                  </p:childTnLst>
+                                </p:cTn>
+                              </p:par>
+                              <p:par>
+                                <p:cTn id="17" presetID="10" presetClass="entr" presetSubtype="0" fill="hold" nodeType="withEffect">
+                                  <p:stCondLst>
+                                    <p:cond delay="1200"/>
+                                  </p:stCondLst>
+                                  <p:childTnLst>
+                                    <p:set>
+                                      <p:cBhvr>
+                                        <p:cTn id="18" dur="1" fill="hold">
+                                          <p:stCondLst>
+                                            <p:cond delay="0"/>
+                                          </p:stCondLst>
+                                        </p:cTn>
+                                        <p:tgtEl>
+                                          <p:spTgt spid="82"/>
+                                        </p:tgtEl>
+                                        <p:attrNameLst>
+                                          <p:attrName>style.visibility</p:attrName>
+                                        </p:attrNameLst>
+                                      </p:cBhvr>
+                                      <p:to>
+                                        <p:strVal val="visible"/>
+                                      </p:to>
+                                    </p:set>
+                                    <p:animEffect transition="in" filter="fade">
+                                      <p:cBhvr>
+                                        <p:cTn id="19" dur="500"/>
+                                        <p:tgtEl>
+                                          <p:spTgt spid="82"/>
+                                        </p:tgtEl>
+                                      </p:cBhvr>
+                                    </p:animEffect>
+                                  </p:childTnLst>
+                                </p:cTn>
+                              </p:par>
+                              <p:par>
+                                <p:cTn id="20" presetID="10" presetClass="entr" presetSubtype="0" fill="hold" nodeType="withEffect">
+                                  <p:stCondLst>
+                                    <p:cond delay="1500"/>
+                                  </p:stCondLst>
+                                  <p:childTnLst>
+                                    <p:set>
+                                      <p:cBhvr>
+                                        <p:cTn id="21" dur="1" fill="hold">
+                                          <p:stCondLst>
+                                            <p:cond delay="0"/>
+                                          </p:stCondLst>
+                                        </p:cTn>
+                                        <p:tgtEl>
+                                          <p:spTgt spid="83"/>
+                                        </p:tgtEl>
+                                        <p:attrNameLst>
+                                          <p:attrName>style.visibility</p:attrName>
+                                        </p:attrNameLst>
+                                      </p:cBhvr>
+                                      <p:to>
+                                        <p:strVal val="visible"/>
+                                      </p:to>
+                                    </p:set>
+                                    <p:animEffect transition="in" filter="fade">
+                                      <p:cBhvr>
+                                        <p:cTn id="22" dur="500"/>
+                                        <p:tgtEl>
+                                          <p:spTgt spid="83"/>
+                                        </p:tgtEl>
+                                      </p:cBhvr>
+                                    </p:animEffect>
+                                  </p:childTnLst>
+                                </p:cTn>
+                              </p:par>
+                            </p:childTnLst>
+                          </p:cTn>
+                        </p:par>
+                      </p:childTnLst>
+                    </p:cTn>
+                  </p:par>
+                </p:childTnLst>
+              </p:cTn>
+              <p:prevCondLst>
+                <p:cond evt="onPrev" delay="0">
+                  <p:tgtEl>
+                    <p:sldTgt/>
+                  </p:tgtEl>
+                </p:cond>
+              </p:prevCondLst>
+              <p:nextCondLst>
+                <p:cond evt="onNext" delay="0">
+                  <p:tgtEl>
+                    <p:sldTgt/>
+                  </p:tgtEl>
+                </p:cond>
+              </p:nextCondLst>
+            </p:seq>
+          </p:childTnLst>
+        </p:cTn>
+      </p:par>
+    </p:tnLst>
+  </p:timing>
 </p:sld>
 </file>
 

</xml_diff>